<commit_message>
feat(ppt0717): 슬라이드 5 신설 — init에 쓴 anchor 상세 (build_hybrid_init_scene.py)
- RoMA(기하검증 삼각측량)+Sobel-PPM(SLAM보정 depth-lift)+SLAM 3재료를
  4cm voxel(RoMA 우선)로 병합 후, exp43 depth-anchor field(w=ρ·d5>0.5)로
  재필터하는 실제 파이프라인을 fig_init_recipe 다이어그램으로 시각화
- 305/12F가 SLAM만으론 재필터 anchor로 부족했던 이유(자기NN p50>0.05m),
  carve 학습 단계의 anchor 선택(305: depth-anchor 재사용 / 12F: SLAM
  control)이 서로 달랐던 점까지 명시
- 기존 슬라이드 5~18을 6~19로 순연, 섹션 범위 라벨 갱신 (총 19장)

Co-Authored-By: Claude Sonnet 5 <noreply@anthropic.com>
Claude-Session: https://claude.ai/code/session_01S3XAkMSxa2MGHVvbytmKvK
</commit_message>
<xml_diff>
--- a/context/ppt/ppt0717/gs_floater_deck_0717.pptx
+++ b/context/ppt/ppt0717/gs_floater_deck_0717.pptx
@@ -30,6 +30,9 @@
     <p:sldId id="278" r:id="rId30"/>
     <p:sldId id="279" r:id="rId31"/>
     <p:sldId id="280" r:id="rId32"/>
+    <p:sldId id="281" r:id="rId33"/>
+    <p:sldId id="282" r:id="rId34"/>
+    <p:sldId id="283" r:id="rId35"/>
   </p:sldIdLst>
   <p:sldSz cx="12191695" cy="6858000" type="screen4x3"/>
   <p:notesSz cx="6858000" cy="9144000"/>
@@ -596,7 +599,7 @@
           <a:lstStyle/>
           <a:p>
             <a:r>
-              <a:t>"이 사이클에서 유일하게 확실히 작동한 두 레버"</a:t>
+              <a:t>"이번 사이클 성과 중 유일하게 '지도 품질'과 무관한 항목 — 그래서 이번 발표에선 짧게만"</a:t>
             </a:r>
           </a:p>
         </p:txBody>
@@ -666,7 +669,7 @@
           <a:lstStyle/>
           <a:p>
             <a:r>
-              <a:t>"이 지점에서 한 번 틀렸다가 사용자 지적으로 바로잡은 이야기로 이어진다"</a:t>
+              <a:t>"이 사이클에서 유일하게 확실히 작동한 두 레버"</a:t>
             </a:r>
           </a:p>
         </p:txBody>
@@ -736,7 +739,7 @@
           <a:lstStyle/>
           <a:p>
             <a:r>
-              <a:t>솔직하게: "숫자 하나를 잘못 놓고 결론을 냈다가 사용자 지적으로 바로잡았다 — 이 정정 자체를 exp51 카드에 남겼다"</a:t>
+              <a:t>"이 지점에서 한 번 틀렸다가 사용자 지적으로 바로잡은 이야기로 이어진다"</a:t>
             </a:r>
           </a:p>
         </p:txBody>
@@ -806,7 +809,7 @@
           <a:lstStyle/>
           <a:p>
             <a:r>
-              <a:t>발표의 핵심 전환점 — "숫자로 헤매던 게 눈으로 보니 바로 답이 나왔다"</a:t>
+              <a:t>솔직하게: "숫자 하나를 잘못 놓고 결론을 냈다가 사용자 지적으로 바로잡았다 — 이 정정 자체를 exp51 카드에 남겼다"</a:t>
             </a:r>
           </a:p>
         </p:txBody>
@@ -876,7 +879,7 @@
           <a:lstStyle/>
           <a:p>
             <a:r>
-              <a:t>"사용자 말대로 이번 사이클 숫자만 보면 화려하지 않다 — 25.29는 30dB대에 한참 못 미친다. 그건 사실이다"</a:t>
+              <a:t>발표의 핵심 전환점 — "숫자로 헤매던 게 눈으로 보니 바로 답이 나왔다"</a:t>
             </a:r>
           </a:p>
         </p:txBody>
@@ -946,7 +949,7 @@
           <a:lstStyle/>
           <a:p>
             <a:r>
-              <a:t>"미해결로 남겨두고 다음 순서(carve)부터 처리하기로 결정"</a:t>
+              <a:t>"사용자 말대로 이번 사이클 숫자만 보면 화려하지 않다 — 25.29는 30dB대에 한참 못 미친다. 그건 사실이다"</a:t>
             </a:r>
           </a:p>
         </p:txBody>
@@ -1016,7 +1019,7 @@
           <a:lstStyle/>
           <a:p>
             <a:r>
-              <a:t>"다음 미팅까지의 단일 목표"</a:t>
+              <a:t>"미해결로 남겨두고 다음 순서(carve)부터 처리하기로 결정"</a:t>
             </a:r>
           </a:p>
         </p:txBody>
@@ -1086,6 +1089,76 @@
           <a:lstStyle/>
           <a:p>
             <a:r>
+              <a:t>"다음 미팅까지의 단일 목표"</a:t>
+            </a:r>
+          </a:p>
+        </p:txBody>
+      </p:sp>
+      <p:sp>
+        <p:nvSpPr>
+          <p:cNvPr id="4" name="Slide Number Placeholder 3"/>
+          <p:cNvSpPr>
+            <a:spLocks noGrp="1"/>
+          </p:cNvSpPr>
+          <p:nvPr>
+            <p:ph type="sldNum" idx="5" sz="quarter"/>
+          </p:nvPr>
+        </p:nvSpPr>
+        <p:spPr/>
+      </p:sp>
+    </p:spTree>
+  </p:cSld>
+  <p:clrMapOvr>
+    <a:masterClrMapping/>
+  </p:clrMapOvr>
+</p:notes>
+</file>
+
+<file path=ppt/notesSlides/notesSlide18.xml><?xml version="1.0" encoding="utf-8"?>
+<p:notes xmlns:a="http://schemas.openxmlformats.org/drawingml/2006/main" xmlns:p="http://schemas.openxmlformats.org/presentationml/2006/main" xmlns:r="http://schemas.openxmlformats.org/officeDocument/2006/relationships">
+  <p:cSld>
+    <p:spTree>
+      <p:nvGrpSpPr>
+        <p:cNvPr id="1" name=""/>
+        <p:cNvGrpSpPr/>
+        <p:nvPr/>
+      </p:nvGrpSpPr>
+      <p:grpSpPr>
+        <a:xfrm>
+          <a:off x="0" y="0"/>
+          <a:ext cx="0" cy="0"/>
+          <a:chOff x="0" y="0"/>
+          <a:chExt cx="0" cy="0"/>
+        </a:xfrm>
+      </p:grpSpPr>
+      <p:sp>
+        <p:nvSpPr>
+          <p:cNvPr id="2" name="Slide Image Placeholder 1"/>
+          <p:cNvSpPr>
+            <a:spLocks noGrp="1"/>
+          </p:cNvSpPr>
+          <p:nvPr>
+            <p:ph type="sldImg" idx="2"/>
+          </p:nvPr>
+        </p:nvSpPr>
+        <p:spPr/>
+      </p:sp>
+      <p:sp>
+        <p:nvSpPr>
+          <p:cNvPr id="3" name="Notes Placeholder 2"/>
+          <p:cNvSpPr>
+            <a:spLocks noGrp="1"/>
+          </p:cNvSpPr>
+          <p:nvPr>
+            <p:ph type="body" idx="3" sz="quarter"/>
+          </p:nvPr>
+        </p:nvSpPr>
+        <p:spPr/>
+        <p:txBody>
+          <a:bodyPr/>
+          <a:lstStyle/>
+          <a:p>
+            <a:r>
               <a:t>사용자의 초기 문제의식에 대한 정면 답변으로 마무리: "화려한 숫자는 없었지만, 뭘 해야 하는지는 확실해졌다"</a:t>
             </a:r>
           </a:p>
@@ -1296,7 +1369,7 @@
           <a:lstStyle/>
           <a:p>
             <a:r>
-              <a:t>"배치 트랙은 이 지점에서 방법론적으로 완결됐다고 판단 — 남은 질문은 incremental로만 답할 수 있다". 오른쪽 렌더 비교가 "화질 무손실" 주장의 직접 증거</a:t>
+              <a:t>"init 개선"이라고만 하면 무슨 마법처럼 들릴 수 있어서 — anchor가 정확히 무엇이었는지(depth-anchor field, exp43에서 이미 만들어둔 자산) 짚고 넘어가는 슬라이드</a:t>
             </a:r>
           </a:p>
         </p:txBody>
@@ -1366,7 +1439,7 @@
           <a:lstStyle/>
           <a:p>
             <a:r>
-              <a:t>CLAUDE.md에 07/17 명문화된 내용 — "왜 배치 트랙에서 갑자기 넘어왔는지"에 대한 답</a:t>
+              <a:t>"배치 트랙은 이 지점에서 방법론적으로 완결됐다고 판단 — 남은 질문은 incremental로만 답할 수 있다". 오른쪽 렌더 비교가 "화질 무손실" 주장의 직접 증거</a:t>
             </a:r>
           </a:p>
         </p:txBody>
@@ -1436,7 +1509,7 @@
           <a:lstStyle/>
           <a:p>
             <a:r>
-              <a:t>"이게 이번 사이클에 곧바로 floater 이식을 안 하고 품질부터 판 이유"</a:t>
+              <a:t>CLAUDE.md에 07/17 명문화된 내용 — "왜 배치 트랙에서 갑자기 넘어왔는지"에 대한 답</a:t>
             </a:r>
           </a:p>
         </p:txBody>
@@ -1506,7 +1579,7 @@
           <a:lstStyle/>
           <a:p>
             <a:r>
-              <a:t>"맨땅에 구현하면서 온라인 3DGS SLAM 논문들이 이미 풀어놓은 문제를 하나씩 재발견하고 있었다 — 그래서 갈아탔다"</a:t>
+              <a:t>"이게 이번 사이클에 곧바로 floater 이식을 안 하고 품질부터 판 이유"</a:t>
             </a:r>
           </a:p>
         </p:txBody>
@@ -1576,7 +1649,7 @@
           <a:lstStyle/>
           <a:p>
             <a:r>
-              <a:t>"같은 예산, 같은 평가 — 아키텍처 하나 바꾼 것만으로 천장을 뚫었다. 자체구현이 틀렸던 것이지 incremental 자체가 안 되는 게 아니었다"</a:t>
+              <a:t>"맨땅에 구현하면서 온라인 3DGS SLAM 논문들이 이미 풀어놓은 문제를 하나씩 재발견하고 있었다 — 그래서 갈아탔다"</a:t>
             </a:r>
           </a:p>
         </p:txBody>
@@ -1646,7 +1719,7 @@
           <a:lstStyle/>
           <a:p>
             <a:r>
-              <a:t>"이번 사이클 성과 중 유일하게 '지도 품질'과 무관한 항목 — 그래서 이번 발표에선 짧게만"</a:t>
+              <a:t>"같은 예산, 같은 평가 — 아키텍처 하나 바꾼 것만으로 천장을 뚫었다. 자체구현이 틀렸던 것이지 incremental 자체가 안 되는 게 아니었다"</a:t>
             </a:r>
           </a:p>
         </p:txBody>
@@ -4760,14 +4833,48 @@
       <p:grpSpPr/>
       <p:sp>
         <p:nvSpPr>
-          <p:cNvPr id="2" name="Rectangle 1"/>
+          <p:cNvPr id="2" name="TextBox 1"/>
+          <p:cNvSpPr txBox="1"/>
+          <p:nvPr/>
+        </p:nvSpPr>
+        <p:spPr>
+          <a:xfrm>
+            <a:off x="502920" y="256032"/>
+            <a:ext cx="11185855" cy="731520"/>
+          </a:xfrm>
+          <a:prstGeom prst="rect">
+            <a:avLst/>
+          </a:prstGeom>
+          <a:noFill/>
+        </p:spPr>
+        <p:txBody>
+          <a:bodyPr wrap="square">
+            <a:spAutoFit/>
+          </a:bodyPr>
+          <a:lstStyle/>
+          <a:p>
+            <a:r>
+              <a:rPr sz="2400" b="1">
+                <a:solidFill>
+                  <a:srgbClr val="1A1A2E"/>
+                </a:solidFill>
+                <a:latin typeface="Noto Sans CJK KR"/>
+              </a:rPr>
+              <a:t>슬라이드 5 — Init 레시피 상세: 어떤 anchor로 만들었나 — 시각자료</a:t>
+            </a:r>
+          </a:p>
+        </p:txBody>
+      </p:sp>
+      <p:sp>
+        <p:nvSpPr>
+          <p:cNvPr id="3" name="Rectangle 2"/>
           <p:cNvSpPr/>
           <p:nvPr/>
         </p:nvSpPr>
         <p:spPr>
           <a:xfrm>
-            <a:off x="0" y="0"/>
-            <a:ext cx="12191695" cy="6858000"/>
+            <a:off x="502920" y="932688"/>
+            <a:ext cx="11185855" cy="31750"/>
           </a:xfrm>
           <a:prstGeom prst="rect">
             <a:avLst/>
@@ -4801,16 +4908,40 @@
           </a:p>
         </p:txBody>
       </p:sp>
-      <p:sp>
-        <p:nvSpPr>
-          <p:cNvPr id="3" name="TextBox 2"/>
+      <p:pic>
+        <p:nvPicPr>
+          <p:cNvPr id="4" name="Picture 3" descr="fig_init_recipe.png"/>
+          <p:cNvPicPr>
+            <a:picLocks noChangeAspect="1"/>
+          </p:cNvPicPr>
+          <p:nvPr/>
+        </p:nvPicPr>
+        <p:blipFill>
+          <a:blip r:embed="rId2"/>
+          <a:stretch>
+            <a:fillRect/>
+          </a:stretch>
+        </p:blipFill>
+        <p:spPr>
+          <a:xfrm>
+            <a:off x="1178790" y="1234440"/>
+            <a:ext cx="9834113" cy="4572000"/>
+          </a:xfrm>
+          <a:prstGeom prst="rect">
+            <a:avLst/>
+          </a:prstGeom>
+        </p:spPr>
+      </p:pic>
+      <p:sp>
+        <p:nvSpPr>
+          <p:cNvPr id="5" name="TextBox 4"/>
           <p:cNvSpPr txBox="1"/>
           <p:nvPr/>
         </p:nvSpPr>
         <p:spPr>
           <a:xfrm>
-            <a:off x="914400" y="2743200"/>
-            <a:ext cx="10362895" cy="1371600"/>
+            <a:off x="502920" y="5943600"/>
+            <a:ext cx="11185855" cy="777240"/>
           </a:xfrm>
           <a:prstGeom prst="rect">
             <a:avLst/>
@@ -4823,15 +4954,20 @@
           </a:bodyPr>
           <a:lstStyle/>
           <a:p>
-            <a:pPr algn="l"/>
-            <a:r>
-              <a:rPr sz="3400" b="1">
-                <a:solidFill>
-                  <a:srgbClr val="FFFFFF"/>
-                </a:solidFill>
-                <a:latin typeface="Noto Sans CJK KR"/>
-              </a:rPr>
-              <a:t>§2. 왜 Incremental로 전환했나 (슬라이드 6–7)</a:t>
+            <a:r>
+              <a:rPr sz="1000">
+                <a:latin typeface="Noto Sans CJK KR"/>
+              </a:rPr>
+              <a:t>🎨 </a:t>
+            </a:r>
+            <a:r>
+              <a:rPr sz="1000" b="0">
+                <a:solidFill>
+                  <a:srgbClr val="8A5A00"/>
+                </a:solidFill>
+                <a:latin typeface="Noto Sans CJK KR"/>
+              </a:rPr>
+              <a:t>init 생성 파이프라인 다이어그램: RoMA/Sobel-PPM/SLAM 3재료 → 4cm voxel 병합(RoMA 우선) → depth-anchor 재필터(w&gt;0.5 제거) → 최종 hybrid init</a:t>
             </a:r>
           </a:p>
         </p:txBody>
@@ -4883,7 +5019,7 @@
                 </a:solidFill>
                 <a:latin typeface="Noto Sans CJK KR"/>
               </a:rPr>
-              <a:t>슬라이드 6 — 최종 목표(North Star) 재확인</a:t>
+              <a:t>슬라이드 6 — exp47: 속도 트랙 — 배치 트랙 실질 종료</a:t>
             </a:r>
           </a:p>
         </p:txBody>
@@ -4969,7 +5105,7 @@
                 </a:solidFill>
                 <a:latin typeface="Noto Sans CJK KR"/>
               </a:rPr>
-              <a:t>완결된 온라인 시스템: </a:t>
+              <a:t>S2(cheapcarve): </a:t>
             </a:r>
             <a:r>
               <a:rPr sz="1500" b="1">
@@ -4978,7 +5114,16 @@
                 </a:solidFill>
                 <a:latin typeface="Noto Sans CJK KR"/>
               </a:rPr>
-              <a:t>Aria 흑백 SLAM 카메라로 실시간 위치추정 + RGB 카메라로 incremental 3DGS 지도 확장</a:t>
+              <a:t>화질 무손실(35.116dB) + 시간 60% 단축(26.8분)</a:t>
+            </a:r>
+            <a:r>
+              <a:rPr sz="1500" b="0">
+                <a:solidFill>
+                  <a:srgbClr val="222222"/>
+                </a:solidFill>
+                <a:latin typeface="Noto Sans CJK KR"/>
+              </a:rPr>
+              <a:t> — 최대 성과</a:t>
             </a:r>
           </a:p>
         </p:txBody>
@@ -5021,16 +5166,7 @@
                 </a:solidFill>
                 <a:latin typeface="Noto Sans CJK KR"/>
               </a:rPr>
-              <a:t>동시 충족 요건: </a:t>
-            </a:r>
-            <a:r>
-              <a:rPr sz="1500" b="1">
-                <a:solidFill>
-                  <a:srgbClr val="222222"/>
-                </a:solidFill>
-                <a:latin typeface="Noto Sans CJK KR"/>
-              </a:rPr>
-              <a:t>고품질(배치급 30dB+) + floater 없음 + 실시간</a:t>
+              <a:t>나머지 조합(S1S4/S4/S5/S6/TARGET) 완주, Pareto 최적점 도출: S2+S4(kf300)+S5(budget235k)+30k = 예상 21~23분/34.4dB</a:t>
             </a:r>
           </a:p>
         </p:txBody>
@@ -5067,94 +5203,22 @@
               <a:t>● </a:t>
             </a:r>
             <a:r>
+              <a:rPr sz="1500" b="1">
+                <a:solidFill>
+                  <a:srgbClr val="222222"/>
+                </a:solidFill>
+                <a:latin typeface="Noto Sans CJK KR"/>
+              </a:rPr>
+              <a:t>여기서 배치 트랙 우선순위 종료</a:t>
+            </a:r>
+            <a:r>
               <a:rPr sz="1500" b="0">
                 <a:solidFill>
                   <a:srgbClr val="222222"/>
                 </a:solidFill>
                 <a:latin typeface="Noto Sans CJK KR"/>
               </a:rPr>
-              <a:t>현재 단계 우선순위: </a:t>
-            </a:r>
-            <a:r>
-              <a:rPr sz="1500" b="1">
-                <a:solidFill>
-                  <a:srgbClr val="222222"/>
-                </a:solidFill>
-                <a:latin typeface="Noto Sans CJK KR"/>
-              </a:rPr>
-              <a:t>①매핑 품질 배치급으로 ②floater 억제 이식 ③라이브 통합</a:t>
-            </a:r>
-            <a:r>
-              <a:rPr sz="1500" b="0">
-                <a:solidFill>
-                  <a:srgbClr val="222222"/>
-                </a:solidFill>
-                <a:latin typeface="Noto Sans CJK KR"/>
-              </a:rPr>
-              <a:t> — 지금은 ①</a:t>
-            </a:r>
-          </a:p>
-        </p:txBody>
-      </p:sp>
-      <p:sp>
-        <p:nvSpPr>
-          <p:cNvPr id="7" name="Rectangle 6"/>
-          <p:cNvSpPr/>
-          <p:nvPr/>
-        </p:nvSpPr>
-        <p:spPr>
-          <a:xfrm>
-            <a:off x="502920" y="2176272"/>
-            <a:ext cx="11185855" cy="457200"/>
-          </a:xfrm>
-          <a:prstGeom prst="rect">
-            <a:avLst/>
-          </a:prstGeom>
-          <a:solidFill>
-            <a:srgbClr val="FFF6E0"/>
-          </a:solidFill>
-          <a:ln w="9525">
-            <a:solidFill>
-              <a:srgbClr val="E0C070"/>
-            </a:solidFill>
-          </a:ln>
-        </p:spPr>
-        <p:style>
-          <a:lnRef idx="1">
-            <a:schemeClr val="accent1"/>
-          </a:lnRef>
-          <a:fillRef idx="3">
-            <a:schemeClr val="accent1"/>
-          </a:fillRef>
-          <a:effectRef idx="2">
-            <a:schemeClr val="accent1"/>
-          </a:effectRef>
-          <a:fontRef idx="minor">
-            <a:schemeClr val="lt1"/>
-          </a:fontRef>
-        </p:style>
-        <p:txBody>
-          <a:bodyPr rtlCol="0" anchor="ctr" wrap="square" lIns="109728"/>
-          <a:lstStyle/>
-          <a:p>
-            <a:pPr algn="ctr"/>
-            <a:r>
-              <a:rPr b="1" sz="1100">
-                <a:solidFill>
-                  <a:srgbClr val="8A5A00"/>
-                </a:solidFill>
-                <a:latin typeface="Noto Sans CJK KR"/>
-              </a:rPr>
-              <a:t>🎨 시각자료  </a:t>
-            </a:r>
-            <a:r>
-              <a:rPr sz="1100" b="0">
-                <a:solidFill>
-                  <a:srgbClr val="8A5A00"/>
-                </a:solidFill>
-                <a:latin typeface="Noto Sans CJK KR"/>
-              </a:rPr>
-              <a:t>North Star 파이프라인 다이어그램(SLAM 흑백 + RGB 매핑 병렬 블록)</a:t>
+              <a:t> — 07/15 밤 결정으로 exp48(incremental)이 최우선 과제로 전환</a:t>
             </a:r>
           </a:p>
         </p:txBody>
@@ -5206,7 +5270,7 @@
                 </a:solidFill>
                 <a:latin typeface="Noto Sans CJK KR"/>
               </a:rPr>
-              <a:t>슬라이드 7 — 왜 순서가 "품질 먼저, floater는 그다음"인가</a:t>
+              <a:t>슬라이드 6 — exp47: 속도 트랙 — 배치 트랙 실질 종료 — 시각자료</a:t>
             </a:r>
           </a:p>
         </p:txBody>
@@ -5254,16 +5318,64 @@
           </a:p>
         </p:txBody>
       </p:sp>
-      <p:sp>
-        <p:nvSpPr>
-          <p:cNvPr id="4" name="TextBox 3"/>
+      <p:pic>
+        <p:nvPicPr>
+          <p:cNvPr id="4" name="Picture 3" descr="fig_speed_pareto.png"/>
+          <p:cNvPicPr>
+            <a:picLocks noChangeAspect="1"/>
+          </p:cNvPicPr>
+          <p:nvPr/>
+        </p:nvPicPr>
+        <p:blipFill>
+          <a:blip r:embed="rId2"/>
+          <a:stretch>
+            <a:fillRect/>
+          </a:stretch>
+        </p:blipFill>
+        <p:spPr>
+          <a:xfrm>
+            <a:off x="502920" y="1792705"/>
+            <a:ext cx="5455767" cy="3455470"/>
+          </a:xfrm>
+          <a:prstGeom prst="rect">
+            <a:avLst/>
+          </a:prstGeom>
+        </p:spPr>
+      </p:pic>
+      <p:pic>
+        <p:nvPicPr>
+          <p:cNvPr id="5" name="Picture 4" descr="fig_12F_lossless.png"/>
+          <p:cNvPicPr>
+            <a:picLocks noChangeAspect="1"/>
+          </p:cNvPicPr>
+          <p:nvPr/>
+        </p:nvPicPr>
+        <p:blipFill>
+          <a:blip r:embed="rId3"/>
+          <a:stretch>
+            <a:fillRect/>
+          </a:stretch>
+        </p:blipFill>
+        <p:spPr>
+          <a:xfrm>
+            <a:off x="6233007" y="1866768"/>
+            <a:ext cx="5455767" cy="3307342"/>
+          </a:xfrm>
+          <a:prstGeom prst="rect">
+            <a:avLst/>
+          </a:prstGeom>
+        </p:spPr>
+      </p:pic>
+      <p:sp>
+        <p:nvSpPr>
+          <p:cNvPr id="6" name="TextBox 5"/>
           <p:cNvSpPr txBox="1"/>
           <p:nvPr/>
         </p:nvSpPr>
         <p:spPr>
           <a:xfrm>
-            <a:off x="502920" y="1051560"/>
-            <a:ext cx="11185855" cy="594360"/>
+            <a:off x="502920" y="5943600"/>
+            <a:ext cx="11185855" cy="777240"/>
           </a:xfrm>
           <a:prstGeom prst="rect">
             <a:avLst/>
@@ -5271,170 +5383,43 @@
           <a:noFill/>
         </p:spPr>
         <p:txBody>
-          <a:bodyPr wrap="square" lIns="0" tIns="0" bIns="0">
+          <a:bodyPr wrap="square">
             <a:spAutoFit/>
           </a:bodyPr>
           <a:lstStyle/>
           <a:p>
             <a:r>
-              <a:rPr sz="1500">
-                <a:solidFill>
-                  <a:srgbClr val="0F4C81"/>
-                </a:solidFill>
-                <a:latin typeface="Noto Sans CJK KR"/>
-              </a:rPr>
-              <a:t>● </a:t>
-            </a:r>
-            <a:r>
-              <a:rPr sz="1500" b="0">
-                <a:solidFill>
-                  <a:srgbClr val="222222"/>
-                </a:solidFill>
-                <a:latin typeface="Noto Sans CJK KR"/>
-              </a:rPr>
-              <a:t>exp43(12F)에서 이미 확인된 사실: </a:t>
-            </a:r>
-            <a:r>
-              <a:rPr sz="1500" b="1">
-                <a:solidFill>
-                  <a:srgbClr val="222222"/>
-                </a:solidFill>
-                <a:latin typeface="Noto Sans CJK KR"/>
-              </a:rPr>
-              <a:t>저품질 지도에선 이미지가 floater를 요구한다</a:t>
-            </a:r>
-            <a:r>
-              <a:rPr sz="1500" b="0">
-                <a:solidFill>
-                  <a:srgbClr val="222222"/>
-                </a:solidFill>
-                <a:latin typeface="Noto Sans CJK KR"/>
-              </a:rPr>
-              <a:t> — carve 압력을 넣어도 photometric gradient가 이김(exp43 "탐지≠제거" 결론과 동일 역학)</a:t>
-            </a:r>
-          </a:p>
-        </p:txBody>
-      </p:sp>
-      <p:sp>
-        <p:nvSpPr>
-          <p:cNvPr id="5" name="TextBox 4"/>
-          <p:cNvSpPr txBox="1"/>
-          <p:nvPr/>
-        </p:nvSpPr>
-        <p:spPr>
-          <a:xfrm>
-            <a:off x="502920" y="1700784"/>
-            <a:ext cx="11185855" cy="320040"/>
-          </a:xfrm>
-          <a:prstGeom prst="rect">
-            <a:avLst/>
-          </a:prstGeom>
-          <a:noFill/>
-        </p:spPr>
-        <p:txBody>
-          <a:bodyPr wrap="square" lIns="0" tIns="0" bIns="0">
-            <a:spAutoFit/>
-          </a:bodyPr>
-          <a:lstStyle/>
-          <a:p>
-            <a:r>
-              <a:rPr sz="1500">
-                <a:solidFill>
-                  <a:srgbClr val="0F4C81"/>
-                </a:solidFill>
-                <a:latin typeface="Noto Sans CJK KR"/>
-              </a:rPr>
-              <a:t>● </a:t>
-            </a:r>
-            <a:r>
-              <a:rPr sz="1500" b="0">
-                <a:solidFill>
-                  <a:srgbClr val="222222"/>
-                </a:solidFill>
-                <a:latin typeface="Noto Sans CJK KR"/>
-              </a:rPr>
-              <a:t>22dB짜리 incremental 지도에 먼저 carve를 이식하는 건 </a:t>
-            </a:r>
-            <a:r>
-              <a:rPr sz="1500" b="1">
-                <a:solidFill>
-                  <a:srgbClr val="222222"/>
-                </a:solidFill>
-                <a:latin typeface="Noto Sans CJK KR"/>
-              </a:rPr>
-              <a:t>순서가 틀린 시도</a:t>
-            </a:r>
-            <a:r>
-              <a:rPr sz="1500" b="0">
-                <a:solidFill>
-                  <a:srgbClr val="222222"/>
-                </a:solidFill>
-                <a:latin typeface="Noto Sans CJK KR"/>
-              </a:rPr>
-              <a:t> — 배치급 품질을 먼저 만들어야 carve가 통함</a:t>
-            </a:r>
-          </a:p>
-        </p:txBody>
-      </p:sp>
-      <p:sp>
-        <p:nvSpPr>
-          <p:cNvPr id="6" name="Rectangle 5"/>
-          <p:cNvSpPr/>
-          <p:nvPr/>
-        </p:nvSpPr>
-        <p:spPr>
-          <a:xfrm>
-            <a:off x="502920" y="2075688"/>
-            <a:ext cx="11185855" cy="457200"/>
-          </a:xfrm>
-          <a:prstGeom prst="rect">
-            <a:avLst/>
-          </a:prstGeom>
-          <a:solidFill>
-            <a:srgbClr val="FFF6E0"/>
-          </a:solidFill>
-          <a:ln w="9525">
-            <a:solidFill>
-              <a:srgbClr val="E0C070"/>
-            </a:solidFill>
-          </a:ln>
-        </p:spPr>
-        <p:style>
-          <a:lnRef idx="1">
-            <a:schemeClr val="accent1"/>
-          </a:lnRef>
-          <a:fillRef idx="3">
-            <a:schemeClr val="accent1"/>
-          </a:fillRef>
-          <a:effectRef idx="2">
-            <a:schemeClr val="accent1"/>
-          </a:effectRef>
-          <a:fontRef idx="minor">
-            <a:schemeClr val="lt1"/>
-          </a:fontRef>
-        </p:style>
-        <p:txBody>
-          <a:bodyPr rtlCol="0" anchor="ctr" wrap="square" lIns="109728"/>
-          <a:lstStyle/>
-          <a:p>
-            <a:pPr algn="ctr"/>
-            <a:r>
-              <a:rPr b="1" sz="1100">
+              <a:rPr sz="1000">
+                <a:latin typeface="Noto Sans CJK KR"/>
+              </a:rPr>
+              <a:t>🎨 </a:t>
+            </a:r>
+            <a:r>
+              <a:rPr sz="1000" b="0">
                 <a:solidFill>
                   <a:srgbClr val="8A5A00"/>
                 </a:solidFill>
                 <a:latin typeface="Noto Sans CJK KR"/>
               </a:rPr>
-              <a:t>🎨 시각자료  </a:t>
-            </a:r>
-            <a:r>
-              <a:rPr sz="1100" b="0">
+              <a:t>① 시간-PSNR Pareto 산점도(8개 축, S2 초록 강조, TARGET 기각 빨강) ② </a:t>
+            </a:r>
+            <a:r>
+              <a:rPr sz="1000" b="1">
                 <a:solidFill>
                   <a:srgbClr val="8A5A00"/>
                 </a:solidFill>
                 <a:latin typeface="Noto Sans CJK KR"/>
               </a:rPr>
-              <a:t>exp43 12F carve 페어 실험 표 재사용(baseline 32.03 vs carve 31.04 — 오히려 악화)</a:t>
+              <a:t>같은 카메라 시점 실제 렌더</a:t>
+            </a:r>
+            <a:r>
+              <a:rPr sz="1000" b="0">
+                <a:solidFill>
+                  <a:srgbClr val="8A5A00"/>
+                </a:solidFill>
+                <a:latin typeface="Noto Sans CJK KR"/>
+              </a:rPr>
+              <a:t>로 "무손실" 직접 증명: 기준(66분, PSNR 35.07) vs S2(26.8분, 35.116) — 육안으로 차이를 못 찾을 정도로 동일</a:t>
             </a:r>
           </a:p>
         </p:txBody>
@@ -5530,7 +5515,7 @@
                 </a:solidFill>
                 <a:latin typeface="Noto Sans CJK KR"/>
               </a:rPr>
-              <a:t>§3. Incremental 여정 — 서사 (슬라이드 8–14)</a:t>
+              <a:t>§2. 왜 Incremental로 전환했나 (슬라이드 7–8)</a:t>
             </a:r>
           </a:p>
         </p:txBody>
@@ -5582,7 +5567,7 @@
                 </a:solidFill>
                 <a:latin typeface="Noto Sans CJK KR"/>
               </a:rPr>
-              <a:t>슬라이드 8 — exp48: 자체구현의 실패, 18dB 천장</a:t>
+              <a:t>슬라이드 7 — 최종 목표(North Star) 재확인</a:t>
             </a:r>
           </a:p>
         </p:txBody>
@@ -5668,7 +5653,16 @@
                 </a:solidFill>
                 <a:latin typeface="Noto Sans CJK KR"/>
               </a:rPr>
-              <a:t>windowed 3DGS incremental을 처음부터 직접 구현(local window + freeze-when-stable)</a:t>
+              <a:t>완결된 온라인 시스템: </a:t>
+            </a:r>
+            <a:r>
+              <a:rPr sz="1500" b="1">
+                <a:solidFill>
+                  <a:srgbClr val="222222"/>
+                </a:solidFill>
+                <a:latin typeface="Noto Sans CJK KR"/>
+              </a:rPr>
+              <a:t>Aria 흑백 SLAM 카메라로 실시간 위치추정 + RGB 카메라로 incremental 3DGS 지도 확장</a:t>
             </a:r>
           </a:p>
         </p:txBody>
@@ -5711,7 +5705,7 @@
                 </a:solidFill>
                 <a:latin typeface="Noto Sans CJK KR"/>
               </a:rPr>
-              <a:t>여러 처방 시도 — PPM K=3, RoMA dense correspondence, selective opacity reset — 전부 적용해도 </a:t>
+              <a:t>동시 충족 요건: </a:t>
             </a:r>
             <a:r>
               <a:rPr sz="1500" b="1">
@@ -5720,7 +5714,7 @@
                 </a:solidFill>
                 <a:latin typeface="Noto Sans CJK KR"/>
               </a:rPr>
-              <a:t>18.0→18.27dB에서 정체</a:t>
+              <a:t>고품질(배치급 30dB+) + floater 없음 + 실시간</a:t>
             </a:r>
           </a:p>
         </p:txBody>
@@ -5734,7 +5728,7 @@
         <p:spPr>
           <a:xfrm>
             <a:off x="502920" y="1801368"/>
-            <a:ext cx="11185855" cy="594360"/>
+            <a:ext cx="11185855" cy="320040"/>
           </a:xfrm>
           <a:prstGeom prst="rect">
             <a:avLst/>
@@ -5763,7 +5757,7 @@
                 </a:solidFill>
                 <a:latin typeface="Noto Sans CJK KR"/>
               </a:rPr>
-              <a:t>근본 원인 규명: </a:t>
+              <a:t>현재 단계 우선순위: </a:t>
             </a:r>
             <a:r>
               <a:rPr sz="1500" b="1">
@@ -5772,7 +5766,7 @@
                 </a:solidFill>
                 <a:latin typeface="Noto Sans CJK KR"/>
               </a:rPr>
-              <a:t>"윈도우를 벗어나는 순간 그 어떤 설정으로도 다시 여물 기회가 없다"</a:t>
+              <a:t>①매핑 품질 배치급으로 ②floater 억제 이식 ③라이브 통합</a:t>
             </a:r>
             <a:r>
               <a:rPr sz="1500" b="0">
@@ -5781,7 +5775,7 @@
                 </a:solidFill>
                 <a:latin typeface="Noto Sans CJK KR"/>
               </a:rPr>
-              <a:t> — opacity_reset이나 LR 스케줄 문제가 아니라 구조 자체의 결함(ancestor 추적으로 확증)</a:t>
+              <a:t> — 지금은 ①</a:t>
             </a:r>
           </a:p>
         </p:txBody>
@@ -5794,7 +5788,7 @@
         </p:nvSpPr>
         <p:spPr>
           <a:xfrm>
-            <a:off x="502920" y="2450592"/>
+            <a:off x="502920" y="2176272"/>
             <a:ext cx="11185855" cy="457200"/>
           </a:xfrm>
           <a:prstGeom prst="rect">
@@ -5844,7 +5838,7 @@
                 </a:solidFill>
                 <a:latin typeface="Noto Sans CJK KR"/>
               </a:rPr>
-              <a:t>exp48 v1→v4 PSNR 추이 막대, "윈도우 이탈 후 방치" 개념도</a:t>
+              <a:t>North Star 파이프라인 다이어그램(SLAM 흑백 + RGB 매핑 병렬 블록)</a:t>
             </a:r>
           </a:p>
         </p:txBody>
@@ -5896,7 +5890,7 @@
                 </a:solidFill>
                 <a:latin typeface="Noto Sans CJK KR"/>
               </a:rPr>
-              <a:t>슬라이드 9 — exp49: Photo-SLAM 채택 — 아키텍처 전환만으로 +3.9dB</a:t>
+              <a:t>슬라이드 8 — 왜 순서가 "품질 먼저, floater는 그다음"인가</a:t>
             </a:r>
           </a:p>
         </p:txBody>
@@ -5982,7 +5976,25 @@
                 </a:solidFill>
                 <a:latin typeface="Noto Sans CJK KR"/>
               </a:rPr>
-              <a:t>검증된 오픈소스(Photo-SLAM, CVPR24, ORB-SLAM3+GS) 채택 — times-of-use 슬라이딩 윈도우(hard evict 없음)가 이미 densification과 결합된 형태로 구현돼 있음</a:t>
+              <a:t>exp43(12F)에서 이미 확인된 사실: </a:t>
+            </a:r>
+            <a:r>
+              <a:rPr sz="1500" b="1">
+                <a:solidFill>
+                  <a:srgbClr val="222222"/>
+                </a:solidFill>
+                <a:latin typeface="Noto Sans CJK KR"/>
+              </a:rPr>
+              <a:t>저품질 지도에선 이미지가 floater를 요구한다</a:t>
+            </a:r>
+            <a:r>
+              <a:rPr sz="1500" b="0">
+                <a:solidFill>
+                  <a:srgbClr val="222222"/>
+                </a:solidFill>
+                <a:latin typeface="Noto Sans CJK KR"/>
+              </a:rPr>
+              <a:t> — carve 압력을 넣어도 photometric gradient가 이김(exp43 "탐지≠제거" 결론과 동일 역학)</a:t>
             </a:r>
           </a:p>
         </p:txBody>
@@ -6025,81 +6037,38 @@
                 </a:solidFill>
                 <a:latin typeface="Noto Sans CJK KR"/>
               </a:rPr>
-              <a:t>RTX 5070 Ti(Blackwell) + CUDA12.8 환경에 맞춰 빌드 이식 성공</a:t>
-            </a:r>
-          </a:p>
-        </p:txBody>
-      </p:sp>
-      <p:sp>
-        <p:nvSpPr>
-          <p:cNvPr id="6" name="TextBox 5"/>
-          <p:cNvSpPr txBox="1"/>
+              <a:t>22dB짜리 incremental 지도에 먼저 carve를 이식하는 건 </a:t>
+            </a:r>
+            <a:r>
+              <a:rPr sz="1500" b="1">
+                <a:solidFill>
+                  <a:srgbClr val="222222"/>
+                </a:solidFill>
+                <a:latin typeface="Noto Sans CJK KR"/>
+              </a:rPr>
+              <a:t>순서가 틀린 시도</a:t>
+            </a:r>
+            <a:r>
+              <a:rPr sz="1500" b="0">
+                <a:solidFill>
+                  <a:srgbClr val="222222"/>
+                </a:solidFill>
+                <a:latin typeface="Noto Sans CJK KR"/>
+              </a:rPr>
+              <a:t> — 배치급 품질을 먼저 만들어야 carve가 통함</a:t>
+            </a:r>
+          </a:p>
+        </p:txBody>
+      </p:sp>
+      <p:sp>
+        <p:nvSpPr>
+          <p:cNvPr id="6" name="Rectangle 5"/>
+          <p:cNvSpPr/>
           <p:nvPr/>
         </p:nvSpPr>
         <p:spPr>
           <a:xfrm>
             <a:off x="502920" y="2075688"/>
-            <a:ext cx="11185855" cy="320040"/>
-          </a:xfrm>
-          <a:prstGeom prst="rect">
-            <a:avLst/>
-          </a:prstGeom>
-          <a:noFill/>
-        </p:spPr>
-        <p:txBody>
-          <a:bodyPr wrap="square" lIns="0" tIns="0" bIns="0">
-            <a:spAutoFit/>
-          </a:bodyPr>
-          <a:lstStyle/>
-          <a:p>
-            <a:r>
-              <a:rPr sz="1500">
-                <a:solidFill>
-                  <a:srgbClr val="0F4C81"/>
-                </a:solidFill>
-                <a:latin typeface="Noto Sans CJK KR"/>
-              </a:rPr>
-              <a:t>● </a:t>
-            </a:r>
-            <a:r>
-              <a:rPr sz="1500" b="1">
-                <a:solidFill>
-                  <a:srgbClr val="222222"/>
-                </a:solidFill>
-                <a:latin typeface="Noto Sans CJK KR"/>
-              </a:rPr>
-              <a:t>exp48과 완전히 동일한 예산(8,550 iter)에서 held-out PSNR 22.14dB</a:t>
-            </a:r>
-            <a:r>
-              <a:rPr sz="1500" b="0">
-                <a:solidFill>
-                  <a:srgbClr val="222222"/>
-                </a:solidFill>
-                <a:latin typeface="Noto Sans CJK KR"/>
-              </a:rPr>
-              <a:t> — 자체구현 대비 </a:t>
-            </a:r>
-            <a:r>
-              <a:rPr sz="1500" b="1">
-                <a:solidFill>
-                  <a:srgbClr val="222222"/>
-                </a:solidFill>
-                <a:latin typeface="Noto Sans CJK KR"/>
-              </a:rPr>
-              <a:t>+3.9dB, 붕괴 뷰(PSNR&lt;15) 41개→5개</a:t>
-            </a:r>
-          </a:p>
-        </p:txBody>
-      </p:sp>
-      <p:sp>
-        <p:nvSpPr>
-          <p:cNvPr id="7" name="Rectangle 6"/>
-          <p:cNvSpPr/>
-          <p:nvPr/>
-        </p:nvSpPr>
-        <p:spPr>
-          <a:xfrm>
-            <a:off x="502920" y="2450592"/>
             <a:ext cx="11185855" cy="457200"/>
           </a:xfrm>
           <a:prstGeom prst="rect">
@@ -6149,7 +6118,7 @@
                 </a:solidFill>
                 <a:latin typeface="Noto Sans CJK KR"/>
               </a:rPr>
-              <a:t>exp48 vs exp49 held-out PSNR 분포 비교(히스토그램)</a:t>
+              <a:t>exp43 12F carve 페어 실험 표 재사용(baseline 32.03 vs carve 31.04 — 오히려 악화)</a:t>
             </a:r>
           </a:p>
         </p:txBody>
@@ -6174,48 +6143,14 @@
       <p:grpSpPr/>
       <p:sp>
         <p:nvSpPr>
-          <p:cNvPr id="2" name="TextBox 1"/>
-          <p:cNvSpPr txBox="1"/>
-          <p:nvPr/>
-        </p:nvSpPr>
-        <p:spPr>
-          <a:xfrm>
-            <a:off x="502920" y="256032"/>
-            <a:ext cx="11185855" cy="731520"/>
-          </a:xfrm>
-          <a:prstGeom prst="rect">
-            <a:avLst/>
-          </a:prstGeom>
-          <a:noFill/>
-        </p:spPr>
-        <p:txBody>
-          <a:bodyPr wrap="square">
-            <a:spAutoFit/>
-          </a:bodyPr>
-          <a:lstStyle/>
-          <a:p>
-            <a:r>
-              <a:rPr sz="2400" b="1">
-                <a:solidFill>
-                  <a:srgbClr val="1A1A2E"/>
-                </a:solidFill>
-                <a:latin typeface="Noto Sans CJK KR"/>
-              </a:rPr>
-              <a:t>슬라이드 10 — exp50 (병행 트랙): 라이브 인프라 — 지금 PSNR엔 안 잡히지만 최종 시스템에 필수</a:t>
-            </a:r>
-          </a:p>
-        </p:txBody>
-      </p:sp>
-      <p:sp>
-        <p:nvSpPr>
-          <p:cNvPr id="3" name="Rectangle 2"/>
+          <p:cNvPr id="2" name="Rectangle 1"/>
           <p:cNvSpPr/>
           <p:nvPr/>
         </p:nvSpPr>
         <p:spPr>
           <a:xfrm>
-            <a:off x="502920" y="932688"/>
-            <a:ext cx="11185855" cy="31750"/>
+            <a:off x="0" y="0"/>
+            <a:ext cx="12191695" cy="6858000"/>
           </a:xfrm>
           <a:prstGeom prst="rect">
             <a:avLst/>
@@ -6251,14 +6186,14 @@
       </p:sp>
       <p:sp>
         <p:nvSpPr>
-          <p:cNvPr id="4" name="TextBox 3"/>
+          <p:cNvPr id="3" name="TextBox 2"/>
           <p:cNvSpPr txBox="1"/>
           <p:nvPr/>
         </p:nvSpPr>
         <p:spPr>
           <a:xfrm>
-            <a:off x="502920" y="1051560"/>
-            <a:ext cx="11185855" cy="320040"/>
+            <a:off x="914400" y="2743200"/>
+            <a:ext cx="10362895" cy="1371600"/>
           </a:xfrm>
           <a:prstGeom prst="rect">
             <a:avLst/>
@@ -6266,204 +6201,20 @@
           <a:noFill/>
         </p:spPr>
         <p:txBody>
-          <a:bodyPr wrap="square" lIns="0" tIns="0" bIns="0">
+          <a:bodyPr wrap="square">
             <a:spAutoFit/>
           </a:bodyPr>
           <a:lstStyle/>
           <a:p>
-            <a:r>
-              <a:rPr sz="1500">
-                <a:solidFill>
-                  <a:srgbClr val="0F4C81"/>
-                </a:solidFill>
-                <a:latin typeface="Noto Sans CJK KR"/>
-              </a:rPr>
-              <a:t>● </a:t>
-            </a:r>
-            <a:r>
-              <a:rPr sz="1500" b="0">
-                <a:solidFill>
-                  <a:srgbClr val="222222"/>
-                </a:solidFill>
-                <a:latin typeface="Noto Sans CJK KR"/>
-              </a:rPr>
-              <a:t>DiskChunGS(ETH, out-of-core 가우시안 SLAM) 빌드 완주 + Aria Fisheye624 흑백 stereo-inertial </a:t>
-            </a:r>
-            <a:r>
-              <a:rPr sz="1500" b="1">
-                <a:solidFill>
-                  <a:srgbClr val="222222"/>
-                </a:solidFill>
-                <a:latin typeface="Noto Sans CJK KR"/>
-              </a:rPr>
-              <a:t>라이브 트래킹 최초 성공</a:t>
-            </a:r>
-          </a:p>
-        </p:txBody>
-      </p:sp>
-      <p:sp>
-        <p:nvSpPr>
-          <p:cNvPr id="5" name="TextBox 4"/>
-          <p:cNvSpPr txBox="1"/>
-          <p:nvPr/>
-        </p:nvSpPr>
-        <p:spPr>
-          <a:xfrm>
-            <a:off x="502920" y="1426464"/>
-            <a:ext cx="11185855" cy="320040"/>
-          </a:xfrm>
-          <a:prstGeom prst="rect">
-            <a:avLst/>
-          </a:prstGeom>
-          <a:noFill/>
-        </p:spPr>
-        <p:txBody>
-          <a:bodyPr wrap="square" lIns="0" tIns="0" bIns="0">
-            <a:spAutoFit/>
-          </a:bodyPr>
-          <a:lstStyle/>
-          <a:p>
-            <a:r>
-              <a:rPr sz="1500">
-                <a:solidFill>
-                  <a:srgbClr val="0F4C81"/>
-                </a:solidFill>
-                <a:latin typeface="Noto Sans CJK KR"/>
-              </a:rPr>
-              <a:t>● </a:t>
-            </a:r>
-            <a:r>
-              <a:rPr sz="1500" b="0">
-                <a:solidFill>
-                  <a:srgbClr val="222222"/>
-                </a:solidFill>
-                <a:latin typeface="Noto Sans CJK KR"/>
-              </a:rPr>
-              <a:t>근본 원인 2건 수정: 잘못된 카메라 모델 캐스팅(UB), fisheye 매칭 경로 미호출 버그</a:t>
-            </a:r>
-          </a:p>
-        </p:txBody>
-      </p:sp>
-      <p:sp>
-        <p:nvSpPr>
-          <p:cNvPr id="6" name="TextBox 5"/>
-          <p:cNvSpPr txBox="1"/>
-          <p:nvPr/>
-        </p:nvSpPr>
-        <p:spPr>
-          <a:xfrm>
-            <a:off x="502920" y="1801368"/>
-            <a:ext cx="11185855" cy="320040"/>
-          </a:xfrm>
-          <a:prstGeom prst="rect">
-            <a:avLst/>
-          </a:prstGeom>
-          <a:noFill/>
-        </p:spPr>
-        <p:txBody>
-          <a:bodyPr wrap="square" lIns="0" tIns="0" bIns="0">
-            <a:spAutoFit/>
-          </a:bodyPr>
-          <a:lstStyle/>
-          <a:p>
-            <a:r>
-              <a:rPr sz="1500">
-                <a:solidFill>
-                  <a:srgbClr val="0F4C81"/>
-                </a:solidFill>
-                <a:latin typeface="Noto Sans CJK KR"/>
-              </a:rPr>
-              <a:t>● </a:t>
-            </a:r>
-            <a:r>
-              <a:rPr sz="1500" b="0">
-                <a:solidFill>
-                  <a:srgbClr val="222222"/>
-                </a:solidFill>
-                <a:latin typeface="Noto Sans CJK KR"/>
-              </a:rPr>
-              <a:t>이건 </a:t>
-            </a:r>
-            <a:r>
-              <a:rPr sz="1500" b="1">
-                <a:solidFill>
-                  <a:srgbClr val="222222"/>
-                </a:solidFill>
-                <a:latin typeface="Noto Sans CJK KR"/>
-              </a:rPr>
-              <a:t>매핑 품질과 별개로, "북극성" 3단계(라이브 통합) 준비물</a:t>
-            </a:r>
-            <a:r>
-              <a:rPr sz="1500" b="0">
-                <a:solidFill>
-                  <a:srgbClr val="222222"/>
-                </a:solidFill>
-                <a:latin typeface="Noto Sans CJK KR"/>
-              </a:rPr>
-              <a:t> — Aria 흑백 SLAM에서 실시간 pose를 뽑는 절반의 시스템이 이미 동작</a:t>
-            </a:r>
-          </a:p>
-        </p:txBody>
-      </p:sp>
-      <p:sp>
-        <p:nvSpPr>
-          <p:cNvPr id="7" name="Rectangle 6"/>
-          <p:cNvSpPr/>
-          <p:nvPr/>
-        </p:nvSpPr>
-        <p:spPr>
-          <a:xfrm>
-            <a:off x="502920" y="2176272"/>
-            <a:ext cx="11185855" cy="457200"/>
-          </a:xfrm>
-          <a:prstGeom prst="rect">
-            <a:avLst/>
-          </a:prstGeom>
-          <a:solidFill>
-            <a:srgbClr val="FFF6E0"/>
-          </a:solidFill>
-          <a:ln w="9525">
-            <a:solidFill>
-              <a:srgbClr val="E0C070"/>
-            </a:solidFill>
-          </a:ln>
-        </p:spPr>
-        <p:style>
-          <a:lnRef idx="1">
-            <a:schemeClr val="accent1"/>
-          </a:lnRef>
-          <a:fillRef idx="3">
-            <a:schemeClr val="accent1"/>
-          </a:fillRef>
-          <a:effectRef idx="2">
-            <a:schemeClr val="accent1"/>
-          </a:effectRef>
-          <a:fontRef idx="minor">
-            <a:schemeClr val="lt1"/>
-          </a:fontRef>
-        </p:style>
-        <p:txBody>
-          <a:bodyPr rtlCol="0" anchor="ctr" wrap="square" lIns="109728"/>
-          <a:lstStyle/>
-          <a:p>
-            <a:pPr algn="ctr"/>
-            <a:r>
-              <a:rPr b="1" sz="1100">
-                <a:solidFill>
-                  <a:srgbClr val="8A5A00"/>
-                </a:solidFill>
-                <a:latin typeface="Noto Sans CJK KR"/>
-              </a:rPr>
-              <a:t>🎨 시각자료  </a:t>
-            </a:r>
-            <a:r>
-              <a:rPr sz="1100" b="0">
-                <a:solidFill>
-                  <a:srgbClr val="8A5A00"/>
-                </a:solidFill>
-                <a:latin typeface="Noto Sans CJK KR"/>
-              </a:rPr>
-              <a:t>Fisheye624 stereo 매칭 개수 before/after(9~31개→33~76개), 라이브 트래킹 스크린샷</a:t>
+            <a:pPr algn="l"/>
+            <a:r>
+              <a:rPr sz="3400" b="1">
+                <a:solidFill>
+                  <a:srgbClr val="FFFFFF"/>
+                </a:solidFill>
+                <a:latin typeface="Noto Sans CJK KR"/>
+              </a:rPr>
+              <a:t>§3. Incremental 여정 — 서사 (슬라이드 9–15)</a:t>
             </a:r>
           </a:p>
         </p:txBody>
@@ -6515,7 +6266,7 @@
                 </a:solidFill>
                 <a:latin typeface="Noto Sans CJK KR"/>
               </a:rPr>
-              <a:t>슬라이드 11 — exp51 축A+B: depth supervision + init 중복방지 — 실측 레버</a:t>
+              <a:t>슬라이드 9 — exp48: 자체구현의 실패, 18dB 천장</a:t>
             </a:r>
           </a:p>
         </p:txBody>
@@ -6572,7 +6323,7 @@
         <p:spPr>
           <a:xfrm>
             <a:off x="502920" y="1051560"/>
-            <a:ext cx="11185855" cy="594360"/>
+            <a:ext cx="11185855" cy="320040"/>
           </a:xfrm>
           <a:prstGeom prst="rect">
             <a:avLst/>
@@ -6601,7 +6352,7 @@
                 </a:solidFill>
                 <a:latin typeface="Noto Sans CJK KR"/>
               </a:rPr>
-              <a:t>VIGS-SLAM(ECCV2026) 조사에서 착안: 우리는 RGB photometric loss만 쓰고 있었고, depth supervision이 빠진 게 진짜 병목일 수 있다는 가설</a:t>
+              <a:t>windowed 3DGS incremental을 처음부터 직접 구현(local window + freeze-when-stable)</a:t>
             </a:r>
           </a:p>
         </p:txBody>
@@ -6614,8 +6365,8 @@
         </p:nvSpPr>
         <p:spPr>
           <a:xfrm>
-            <a:off x="502920" y="1700784"/>
-            <a:ext cx="11185855" cy="594360"/>
+            <a:off x="502920" y="1426464"/>
+            <a:ext cx="11185855" cy="320040"/>
           </a:xfrm>
           <a:prstGeom prst="rect">
             <a:avLst/>
@@ -6638,31 +6389,22 @@
               <a:t>● </a:t>
             </a:r>
             <a:r>
+              <a:rPr sz="1500" b="0">
+                <a:solidFill>
+                  <a:srgbClr val="222222"/>
+                </a:solidFill>
+                <a:latin typeface="Noto Sans CJK KR"/>
+              </a:rPr>
+              <a:t>여러 처방 시도 — PPM K=3, RoMA dense correspondence, selective opacity reset — 전부 적용해도 </a:t>
+            </a:r>
+            <a:r>
               <a:rPr sz="1500" b="1">
                 <a:solidFill>
                   <a:srgbClr val="222222"/>
                 </a:solidFill>
                 <a:latin typeface="Noto Sans CJK KR"/>
               </a:rPr>
-              <a:t>축A(depth supervision)</a:t>
-            </a:r>
-            <a:r>
-              <a:rPr sz="1500" b="0">
-                <a:solidFill>
-                  <a:srgbClr val="222222"/>
-                </a:solidFill>
-                <a:latin typeface="Noto Sans CJK KR"/>
-              </a:rPr>
-              <a:t>: Photo-SLAM CUDA 래스터라이저에 depth 출력 이식(3dgs-custom 패턴 포팅), SLAM-보정 depth-pro를 타깃으로 추가 → λ=0.5에서 </a:t>
-            </a:r>
-            <a:r>
-              <a:rPr sz="1500" b="1">
-                <a:solidFill>
-                  <a:srgbClr val="222222"/>
-                </a:solidFill>
-                <a:latin typeface="Noto Sans CJK KR"/>
-              </a:rPr>
-              <a:t>22.87→25.29dB (+2.42dB, 최고)</a:t>
+              <a:t>18.0→18.27dB에서 정체</a:t>
             </a:r>
           </a:p>
         </p:txBody>
@@ -6675,8 +6417,8 @@
         </p:nvSpPr>
         <p:spPr>
           <a:xfrm>
-            <a:off x="502920" y="2350008"/>
-            <a:ext cx="11185855" cy="320040"/>
+            <a:off x="502920" y="1801368"/>
+            <a:ext cx="11185855" cy="594360"/>
           </a:xfrm>
           <a:prstGeom prst="rect">
             <a:avLst/>
@@ -6699,13 +6441,22 @@
               <a:t>● </a:t>
             </a:r>
             <a:r>
+              <a:rPr sz="1500" b="0">
+                <a:solidFill>
+                  <a:srgbClr val="222222"/>
+                </a:solidFill>
+                <a:latin typeface="Noto Sans CJK KR"/>
+              </a:rPr>
+              <a:t>근본 원인 규명: </a:t>
+            </a:r>
+            <a:r>
               <a:rPr sz="1500" b="1">
                 <a:solidFill>
                   <a:srgbClr val="222222"/>
                 </a:solidFill>
                 <a:latin typeface="Noto Sans CJK KR"/>
               </a:rPr>
-              <a:t>축B(init 렌더-alpha 중복방지)</a:t>
+              <a:t>"윈도우를 벗어나는 순간 그 어떤 설정으로도 다시 여물 기회가 없다"</a:t>
             </a:r>
             <a:r>
               <a:rPr sz="1500" b="0">
@@ -6714,16 +6465,7 @@
                 </a:solidFill>
                 <a:latin typeface="Noto Sans CJK KR"/>
               </a:rPr>
-              <a:t>: 새 keyframe 추가 시 이미 렌더로 덮인 영역엔 점을 새로 안 만듦 → PSNR 무변화, 가우시안 수 </a:t>
-            </a:r>
-            <a:r>
-              <a:rPr sz="1500" b="1">
-                <a:solidFill>
-                  <a:srgbClr val="222222"/>
-                </a:solidFill>
-                <a:latin typeface="Noto Sans CJK KR"/>
-              </a:rPr>
-              <a:t>-16%</a:t>
+              <a:t> — opacity_reset이나 LR 스케줄 문제가 아니라 구조 자체의 결함(ancestor 추적으로 확증)</a:t>
             </a:r>
           </a:p>
         </p:txBody>
@@ -6736,7 +6478,7 @@
         </p:nvSpPr>
         <p:spPr>
           <a:xfrm>
-            <a:off x="502920" y="2724912"/>
+            <a:off x="502920" y="2450592"/>
             <a:ext cx="11185855" cy="457200"/>
           </a:xfrm>
           <a:prstGeom prst="rect">
@@ -6786,7 +6528,7 @@
                 </a:solidFill>
                 <a:latin typeface="Noto Sans CJK KR"/>
               </a:rPr>
-              <a:t>λ 스캔 곡선(0/0.1/0.5/1.0), dedup 전후 가우시안 수 막대</a:t>
+              <a:t>exp48 v1→v4 PSNR 추이 막대, "윈도우 이탈 후 방치" 개념도</a:t>
             </a:r>
           </a:p>
         </p:txBody>
@@ -6838,7 +6580,7 @@
                 </a:solidFill>
                 <a:latin typeface="Noto Sans CJK KR"/>
               </a:rPr>
-              <a:t>슬라이드 12 — exp51 축C+F: "더 넣으면 되겠지"가 틀렸다</a:t>
+              <a:t>슬라이드 10 — exp49: Photo-SLAM 채택 — 아키텍처 전환만으로 +3.9dB</a:t>
             </a:r>
           </a:p>
         </p:txBody>
@@ -6895,7 +6637,7 @@
         <p:spPr>
           <a:xfrm>
             <a:off x="502920" y="1051560"/>
-            <a:ext cx="11185855" cy="320040"/>
+            <a:ext cx="11185855" cy="594360"/>
           </a:xfrm>
           <a:prstGeom prst="rect">
             <a:avLst/>
@@ -6918,31 +6660,13 @@
               <a:t>● </a:t>
             </a:r>
             <a:r>
-              <a:rPr sz="1500" b="1">
-                <a:solidFill>
-                  <a:srgbClr val="222222"/>
-                </a:solidFill>
-                <a:latin typeface="Noto Sans CJK KR"/>
-              </a:rPr>
-              <a:t>축C(keyframe 밀도 2배)</a:t>
-            </a:r>
-            <a:r>
               <a:rPr sz="1500" b="0">
                 <a:solidFill>
                   <a:srgbClr val="222222"/>
                 </a:solidFill>
                 <a:latin typeface="Noto Sans CJK KR"/>
               </a:rPr>
-              <a:t>: 57→113 서브청크, 고정예산·비례예산 두 방식 모두 재검증 → </a:t>
-            </a:r>
-            <a:r>
-              <a:rPr sz="1500" b="1">
-                <a:solidFill>
-                  <a:srgbClr val="222222"/>
-                </a:solidFill>
-                <a:latin typeface="Noto Sans CJK KR"/>
-              </a:rPr>
-              <a:t>25.11~25.30dB, 축A+B와 오차범위 내로 무효과</a:t>
+              <a:t>검증된 오픈소스(Photo-SLAM, CVPR24, ORB-SLAM3+GS) 채택 — times-of-use 슬라이딩 윈도우(hard evict 없음)가 이미 densification과 결합된 형태로 구현돼 있음</a:t>
             </a:r>
           </a:p>
         </p:txBody>
@@ -6955,7 +6679,7 @@
         </p:nvSpPr>
         <p:spPr>
           <a:xfrm>
-            <a:off x="502920" y="1426464"/>
+            <a:off x="502920" y="1700784"/>
             <a:ext cx="11185855" cy="320040"/>
           </a:xfrm>
           <a:prstGeom prst="rect">
@@ -6979,40 +6703,13 @@
               <a:t>● </a:t>
             </a:r>
             <a:r>
-              <a:rPr sz="1500" b="1">
-                <a:solidFill>
-                  <a:srgbClr val="222222"/>
-                </a:solidFill>
-                <a:latin typeface="Noto Sans CJK KR"/>
-              </a:rPr>
-              <a:t>축F(학습 예산 3.3배, 28,581 iter)</a:t>
-            </a:r>
-            <a:r>
               <a:rPr sz="1500" b="0">
                 <a:solidFill>
                   <a:srgbClr val="222222"/>
                 </a:solidFill>
                 <a:latin typeface="Noto Sans CJK KR"/>
               </a:rPr>
-              <a:t>: </a:t>
-            </a:r>
-            <a:r>
-              <a:rPr sz="1500" b="1">
-                <a:solidFill>
-                  <a:srgbClr val="222222"/>
-                </a:solidFill>
-                <a:latin typeface="Noto Sans CJK KR"/>
-              </a:rPr>
-              <a:t>25.59dB, +0.30만</a:t>
-            </a:r>
-            <a:r>
-              <a:rPr sz="1500" b="0">
-                <a:solidFill>
-                  <a:srgbClr val="222222"/>
-                </a:solidFill>
-                <a:latin typeface="Noto Sans CJK KR"/>
-              </a:rPr>
-              <a:t> — 예산을 대폭 늘려도 거의 안 움직임</a:t>
+              <a:t>RTX 5070 Ti(Blackwell) + CUDA12.8 환경에 맞춰 빌드 이식 성공</a:t>
             </a:r>
           </a:p>
         </p:txBody>
@@ -7025,7 +6722,7 @@
         </p:nvSpPr>
         <p:spPr>
           <a:xfrm>
-            <a:off x="502920" y="1801368"/>
+            <a:off x="502920" y="2075688"/>
             <a:ext cx="11185855" cy="320040"/>
           </a:xfrm>
           <a:prstGeom prst="rect">
@@ -7049,13 +6746,22 @@
               <a:t>● </a:t>
             </a:r>
             <a:r>
+              <a:rPr sz="1500" b="1">
+                <a:solidFill>
+                  <a:srgbClr val="222222"/>
+                </a:solidFill>
+                <a:latin typeface="Noto Sans CJK KR"/>
+              </a:rPr>
+              <a:t>exp48과 완전히 동일한 예산(8,550 iter)에서 held-out PSNR 22.14dB</a:t>
+            </a:r>
+            <a:r>
               <a:rPr sz="1500" b="0">
                 <a:solidFill>
                   <a:srgbClr val="222222"/>
                 </a:solidFill>
                 <a:latin typeface="Noto Sans CJK KR"/>
               </a:rPr>
-              <a:t>Photo-SLAM 키프레임 샘플러 코드 직접 확인: 최근 키프레임 편향이 아니라 </a:t>
+              <a:t> — 자체구현 대비 </a:t>
             </a:r>
             <a:r>
               <a:rPr sz="1500" b="1">
@@ -7064,81 +6770,20 @@
                 </a:solidFill>
                 <a:latin typeface="Noto Sans CJK KR"/>
               </a:rPr>
-              <a:t>등록된 전원을 균등 순환</a:t>
-            </a:r>
-            <a:r>
-              <a:rPr sz="1500" b="0">
-                <a:solidFill>
-                  <a:srgbClr val="222222"/>
-                </a:solidFill>
-                <a:latin typeface="Noto Sans CJK KR"/>
-              </a:rPr>
-              <a:t> — "재방문 편향" 가설도 기각</a:t>
-            </a:r>
-          </a:p>
-        </p:txBody>
-      </p:sp>
-      <p:sp>
-        <p:nvSpPr>
-          <p:cNvPr id="7" name="TextBox 6"/>
-          <p:cNvSpPr txBox="1"/>
-          <p:nvPr/>
-        </p:nvSpPr>
-        <p:spPr>
-          <a:xfrm>
-            <a:off x="502920" y="2176272"/>
-            <a:ext cx="11185855" cy="320040"/>
-          </a:xfrm>
-          <a:prstGeom prst="rect">
-            <a:avLst/>
-          </a:prstGeom>
-          <a:noFill/>
-        </p:spPr>
-        <p:txBody>
-          <a:bodyPr wrap="square" lIns="0" tIns="0" bIns="0">
-            <a:spAutoFit/>
-          </a:bodyPr>
-          <a:lstStyle/>
-          <a:p>
-            <a:r>
-              <a:rPr sz="1500">
-                <a:solidFill>
-                  <a:srgbClr val="0F4C81"/>
-                </a:solidFill>
-                <a:latin typeface="Noto Sans CJK KR"/>
-              </a:rPr>
-              <a:t>● </a:t>
-            </a:r>
-            <a:r>
-              <a:rPr sz="1500" b="1">
-                <a:solidFill>
-                  <a:srgbClr val="222222"/>
-                </a:solidFill>
-                <a:latin typeface="Noto Sans CJK KR"/>
-              </a:rPr>
-              <a:t>밀도·예산·재방문 편향 전부 아니라는 게 이 세 실험으로 확정</a:t>
-            </a:r>
-            <a:r>
-              <a:rPr sz="1500" b="0">
-                <a:solidFill>
-                  <a:srgbClr val="222222"/>
-                </a:solidFill>
-                <a:latin typeface="Noto Sans CJK KR"/>
-              </a:rPr>
-              <a:t> — 그럼 뭐가 문제인가?</a:t>
-            </a:r>
-          </a:p>
-        </p:txBody>
-      </p:sp>
-      <p:sp>
-        <p:nvSpPr>
-          <p:cNvPr id="8" name="Rectangle 7"/>
+              <a:t>+3.9dB, 붕괴 뷰(PSNR&lt;15) 41개→5개</a:t>
+            </a:r>
+          </a:p>
+        </p:txBody>
+      </p:sp>
+      <p:sp>
+        <p:nvSpPr>
+          <p:cNvPr id="7" name="Rectangle 6"/>
           <p:cNvSpPr/>
           <p:nvPr/>
         </p:nvSpPr>
         <p:spPr>
           <a:xfrm>
-            <a:off x="502920" y="2551176"/>
+            <a:off x="502920" y="2450592"/>
             <a:ext cx="11185855" cy="457200"/>
           </a:xfrm>
           <a:prstGeom prst="rect">
@@ -7188,7 +6833,7 @@
                 </a:solidFill>
                 <a:latin typeface="Noto Sans CJK KR"/>
               </a:rPr>
-              <a:t>밀도/예산 스캔 결과 막대(전부 25dB대에 수렴)</a:t>
+              <a:t>exp48 vs exp49 held-out PSNR 분포 비교(히스토그램)</a:t>
             </a:r>
           </a:p>
         </p:txBody>
@@ -7240,7 +6885,7 @@
                 </a:solidFill>
                 <a:latin typeface="Noto Sans CJK KR"/>
               </a:rPr>
-              <a:t>슬라이드 13 — 자기수정: "배치 30.2dB가 상한"이라는 착각</a:t>
+              <a:t>슬라이드 11 — exp50 (병행 트랙): 라이브 인프라 — 지금 PSNR엔 안 잡히지만 최종 시스템에 필수</a:t>
             </a:r>
           </a:p>
         </p:txBody>
@@ -7326,7 +6971,7 @@
                 </a:solidFill>
                 <a:latin typeface="Noto Sans CJK KR"/>
               </a:rPr>
-              <a:t>축C/F 결과를 두고 처음엔 </a:t>
+              <a:t>DiskChunGS(ETH, out-of-core 가우시안 SLAM) 빌드 완주 + Aria Fisheye624 흑백 stereo-inertial </a:t>
             </a:r>
             <a:r>
               <a:rPr sz="1500" b="1">
@@ -7335,16 +6980,7 @@
                 </a:solidFill>
                 <a:latin typeface="Noto Sans CJK KR"/>
               </a:rPr>
-              <a:t>"장면 콘텐츠 난이도(저텍스처+specular) 때문에 30.2dB가 이 장면의 사실상 상한"</a:t>
-            </a:r>
-            <a:r>
-              <a:rPr sz="1500" b="0">
-                <a:solidFill>
-                  <a:srgbClr val="222222"/>
-                </a:solidFill>
-                <a:latin typeface="Noto Sans CJK KR"/>
-              </a:rPr>
-              <a:t>이라고 결론 내렸음</a:t>
+              <a:t>라이브 트래킹 최초 성공</a:t>
             </a:r>
           </a:p>
         </p:txBody>
@@ -7358,7 +6994,7 @@
         <p:spPr>
           <a:xfrm>
             <a:off x="502920" y="1426464"/>
-            <a:ext cx="11185855" cy="594360"/>
+            <a:ext cx="11185855" cy="320040"/>
           </a:xfrm>
           <a:prstGeom prst="rect">
             <a:avLst/>
@@ -7381,40 +7017,13 @@
               <a:t>● </a:t>
             </a:r>
             <a:r>
-              <a:rPr sz="1500" b="1">
-                <a:solidFill>
-                  <a:srgbClr val="222222"/>
-                </a:solidFill>
-                <a:latin typeface="Noto Sans CJK KR"/>
-              </a:rPr>
-              <a:t>사용자 지적("일반 3dgs로 33 나왔었는데")으로 발견</a:t>
-            </a:r>
-            <a:r>
               <a:rPr sz="1500" b="0">
                 <a:solidFill>
                   <a:srgbClr val="222222"/>
                 </a:solidFill>
                 <a:latin typeface="Noto Sans CJK KR"/>
               </a:rPr>
-              <a:t>: 30.2dB는 exp48 시절 </a:t>
-            </a:r>
-            <a:r>
-              <a:rPr sz="1500" b="1">
-                <a:solidFill>
-                  <a:srgbClr val="222222"/>
-                </a:solidFill>
-                <a:latin typeface="Noto Sans CJK KR"/>
-              </a:rPr>
-              <a:t>8,550 iteration으로 예산을 캡 씌운 통제실험</a:t>
-            </a:r>
-            <a:r>
-              <a:rPr sz="1500" b="0">
-                <a:solidFill>
-                  <a:srgbClr val="222222"/>
-                </a:solidFill>
-                <a:latin typeface="Noto Sans CJK KR"/>
-              </a:rPr>
-              <a:t> 수치였을 뿐, 진짜 배치 상한이 아니었음</a:t>
+              <a:t>근본 원인 2건 수정: 잘못된 카메라 모델 캐스팅(UB), fisheye 매칭 경로 미호출 버그</a:t>
             </a:r>
           </a:p>
         </p:txBody>
@@ -7427,8 +7036,8 @@
         </p:nvSpPr>
         <p:spPr>
           <a:xfrm>
-            <a:off x="502920" y="2075688"/>
-            <a:ext cx="11185855" cy="594360"/>
+            <a:off x="502920" y="1801368"/>
+            <a:ext cx="11185855" cy="320040"/>
           </a:xfrm>
           <a:prstGeom prst="rect">
             <a:avLst/>
@@ -7457,7 +7066,7 @@
                 </a:solidFill>
                 <a:latin typeface="Noto Sans CJK KR"/>
               </a:rPr>
-              <a:t>같은 장면의 </a:t>
+              <a:t>이건 </a:t>
             </a:r>
             <a:r>
               <a:rPr sz="1500" b="1">
@@ -7466,7 +7075,7 @@
                 </a:solidFill>
                 <a:latin typeface="Noto Sans CJK KR"/>
               </a:rPr>
-              <a:t>진짜 풀 30k-iteration 배치 결과</a:t>
+              <a:t>매핑 품질과 별개로, "북극성" 3단계(라이브 통합) 준비물</a:t>
             </a:r>
             <a:r>
               <a:rPr sz="1500" b="0">
@@ -7475,90 +7084,20 @@
                 </a:solidFill>
                 <a:latin typeface="Noto Sans CJK KR"/>
               </a:rPr>
-              <a:t>(exp44_fast_geometry_plan.md에 이미 있었음): baseline(ORB init) test </a:t>
-            </a:r>
-            <a:r>
-              <a:rPr sz="1500" b="1">
-                <a:solidFill>
-                  <a:srgbClr val="222222"/>
-                </a:solidFill>
-                <a:latin typeface="Noto Sans CJK KR"/>
-              </a:rPr>
-              <a:t>31.549dB</a:t>
-            </a:r>
-            <a:r>
-              <a:rPr sz="1500" b="0">
-                <a:solidFill>
-                  <a:srgbClr val="222222"/>
-                </a:solidFill>
-                <a:latin typeface="Noto Sans CJK KR"/>
-              </a:rPr>
-              <a:t>, 챔피언(hybrid init+carve) test </a:t>
-            </a:r>
-            <a:r>
-              <a:rPr sz="1500" b="1">
-                <a:solidFill>
-                  <a:srgbClr val="222222"/>
-                </a:solidFill>
-                <a:latin typeface="Noto Sans CJK KR"/>
-              </a:rPr>
-              <a:t>32.479dB / train 33.799dB</a:t>
-            </a:r>
-          </a:p>
-        </p:txBody>
-      </p:sp>
-      <p:sp>
-        <p:nvSpPr>
-          <p:cNvPr id="7" name="TextBox 6"/>
-          <p:cNvSpPr txBox="1"/>
-          <p:nvPr/>
-        </p:nvSpPr>
-        <p:spPr>
-          <a:xfrm>
-            <a:off x="502920" y="2724912"/>
-            <a:ext cx="11185855" cy="320040"/>
-          </a:xfrm>
-          <a:prstGeom prst="rect">
-            <a:avLst/>
-          </a:prstGeom>
-          <a:noFill/>
-        </p:spPr>
-        <p:txBody>
-          <a:bodyPr wrap="square" lIns="0" tIns="0" bIns="0">
-            <a:spAutoFit/>
-          </a:bodyPr>
-          <a:lstStyle/>
-          <a:p>
-            <a:r>
-              <a:rPr sz="1500">
-                <a:solidFill>
-                  <a:srgbClr val="0F4C81"/>
-                </a:solidFill>
-                <a:latin typeface="Noto Sans CJK KR"/>
-              </a:rPr>
-              <a:t>● </a:t>
-            </a:r>
-            <a:r>
-              <a:rPr sz="1500" b="0">
-                <a:solidFill>
-                  <a:srgbClr val="222222"/>
-                </a:solidFill>
-                <a:latin typeface="Noto Sans CJK KR"/>
-              </a:rPr>
-              <a:t>축A~F는 전부 8,550~28,581 iteration — 배치 30k에 못 미치는 캡 안에서 실험한 것이었음</a:t>
-            </a:r>
-          </a:p>
-        </p:txBody>
-      </p:sp>
-      <p:sp>
-        <p:nvSpPr>
-          <p:cNvPr id="8" name="Rectangle 7"/>
+              <a:t> — Aria 흑백 SLAM에서 실시간 pose를 뽑는 절반의 시스템이 이미 동작</a:t>
+            </a:r>
+          </a:p>
+        </p:txBody>
+      </p:sp>
+      <p:sp>
+        <p:nvSpPr>
+          <p:cNvPr id="7" name="Rectangle 6"/>
           <p:cNvSpPr/>
           <p:nvPr/>
         </p:nvSpPr>
         <p:spPr>
           <a:xfrm>
-            <a:off x="502920" y="3099816"/>
+            <a:off x="502920" y="2176272"/>
             <a:ext cx="11185855" cy="457200"/>
           </a:xfrm>
           <a:prstGeom prst="rect">
@@ -7608,7 +7147,7 @@
                 </a:solidFill>
                 <a:latin typeface="Noto Sans CJK KR"/>
               </a:rPr>
-              <a:t>"30.2dB(가짜 상한) vs 31.5~32.5dB(진짜 상한)" 정정 막대</a:t>
+              <a:t>Fisheye624 stereo 매칭 개수 before/after(9~31개→33~76개), 라이브 트래킹 스크린샷</a:t>
             </a:r>
           </a:p>
         </p:txBody>
@@ -7756,7 +7295,7 @@
                 </a:solidFill>
                 <a:latin typeface="Noto Sans CJK KR"/>
               </a:rPr>
-              <a:t>슬라이드 14 — 시각 진단 확정: 잔여 갭의 정체는 depth-init 바늘형 floater</a:t>
+              <a:t>슬라이드 12 — exp51 축A+B: depth supervision + init 중복방지 — 실측 레버</a:t>
             </a:r>
           </a:p>
         </p:txBody>
@@ -7813,7 +7352,7 @@
         <p:spPr>
           <a:xfrm>
             <a:off x="502920" y="1051560"/>
-            <a:ext cx="11185855" cy="320040"/>
+            <a:ext cx="11185855" cy="594360"/>
           </a:xfrm>
           <a:prstGeom prst="rect">
             <a:avLst/>
@@ -7842,7 +7381,7 @@
                 </a:solidFill>
                 <a:latin typeface="Noto Sans CJK KR"/>
               </a:rPr>
-              <a:t>정정된 상한(31.5~32.5dB)으로 다시 보면 축F(25.59dB)도 여전히 6~7dB 갭 — 밀도·예산·편향 다 아니라면 남은 후보는?</a:t>
+              <a:t>VIGS-SLAM(ECCV2026) 조사에서 착안: 우리는 RGB photometric loss만 쓰고 있었고, depth supervision이 빠진 게 진짜 병목일 수 있다는 가설</a:t>
             </a:r>
           </a:p>
         </p:txBody>
@@ -7855,7 +7394,7 @@
         </p:nvSpPr>
         <p:spPr>
           <a:xfrm>
-            <a:off x="502920" y="1426464"/>
+            <a:off x="502920" y="1700784"/>
             <a:ext cx="11185855" cy="594360"/>
           </a:xfrm>
           <a:prstGeom prst="rect">
@@ -7885,7 +7424,7 @@
                 </a:solidFill>
                 <a:latin typeface="Noto Sans CJK KR"/>
               </a:rPr>
-              <a:t>최악 held-out 뷰(화이트보드+문 장면)의 GT/render를 직접 육안 대조</a:t>
+              <a:t>축A(depth supervision)</a:t>
             </a:r>
             <a:r>
               <a:rPr sz="1500" b="0">
@@ -7894,7 +7433,7 @@
                 </a:solidFill>
                 <a:latin typeface="Noto Sans CJK KR"/>
               </a:rPr>
-              <a:t>: GT는 평범한 실내 장면인데 </a:t>
+              <a:t>: Photo-SLAM CUDA 래스터라이저에 depth 출력 이식(3dgs-custom 패턴 포팅), SLAM-보정 depth-pro를 타깃으로 추가 → λ=0.5에서 </a:t>
             </a:r>
             <a:r>
               <a:rPr sz="1500" b="1">
@@ -7903,16 +7442,7 @@
                 </a:solidFill>
                 <a:latin typeface="Noto Sans CJK KR"/>
               </a:rPr>
-              <a:t>render는 화면 전체가 바늘형(needle) floater 아티팩트로 뒤덮임</a:t>
-            </a:r>
-            <a:r>
-              <a:rPr sz="1500" b="0">
-                <a:solidFill>
-                  <a:srgbClr val="222222"/>
-                </a:solidFill>
-                <a:latin typeface="Noto Sans CJK KR"/>
-              </a:rPr>
-              <a:t> — "블러/저화질"이 아니라 명백한 floater 문제</a:t>
+              <a:t>22.87→25.29dB (+2.42dB, 최고)</a:t>
             </a:r>
           </a:p>
         </p:txBody>
@@ -7925,8 +7455,8 @@
         </p:nvSpPr>
         <p:spPr>
           <a:xfrm>
-            <a:off x="502920" y="2075688"/>
-            <a:ext cx="11185855" cy="594360"/>
+            <a:off x="502920" y="2350008"/>
+            <a:ext cx="11185855" cy="320040"/>
           </a:xfrm>
           <a:prstGeom prst="rect">
             <a:avLst/>
@@ -7949,13 +7479,22 @@
               <a:t>● </a:t>
             </a:r>
             <a:r>
+              <a:rPr sz="1500" b="1">
+                <a:solidFill>
+                  <a:srgbClr val="222222"/>
+                </a:solidFill>
+                <a:latin typeface="Noto Sans CJK KR"/>
+              </a:rPr>
+              <a:t>축B(init 렌더-alpha 중복방지)</a:t>
+            </a:r>
+            <a:r>
               <a:rPr sz="1500" b="0">
                 <a:solidFill>
                   <a:srgbClr val="222222"/>
                 </a:solidFill>
                 <a:latin typeface="Noto Sans CJK KR"/>
               </a:rPr>
-              <a:t>원인 가설: keyframe마다 </a:t>
+              <a:t>: 새 keyframe 추가 시 이미 렌더로 덮인 영역엔 점을 새로 안 만듦 → PSNR 무변화, 가우시안 수 </a:t>
             </a:r>
             <a:r>
               <a:rPr sz="1500" b="1">
@@ -7964,72 +7503,20 @@
                 </a:solidFill>
                 <a:latin typeface="Noto Sans CJK KR"/>
               </a:rPr>
-              <a:t>자기 단일 시점 depth-pro 추정치 하나로만 init</a:t>
-            </a:r>
-            <a:r>
-              <a:rPr sz="1500" b="0">
-                <a:solidFill>
-                  <a:srgbClr val="222222"/>
-                </a:solidFill>
-                <a:latin typeface="Noto Sans CJK KR"/>
-              </a:rPr>
-              <a:t>되어 specular/저텍스처 구간에서 처음부터 잘못 앵커링되고, 배치처럼 겹치는 여러 시점이 교차검증할 기회가 없어 안 고쳐짐</a:t>
-            </a:r>
-          </a:p>
-        </p:txBody>
-      </p:sp>
-      <p:sp>
-        <p:nvSpPr>
-          <p:cNvPr id="7" name="TextBox 6"/>
-          <p:cNvSpPr txBox="1"/>
+              <a:t>-16%</a:t>
+            </a:r>
+          </a:p>
+        </p:txBody>
+      </p:sp>
+      <p:sp>
+        <p:nvSpPr>
+          <p:cNvPr id="7" name="Rectangle 6"/>
+          <p:cNvSpPr/>
           <p:nvPr/>
         </p:nvSpPr>
         <p:spPr>
           <a:xfrm>
             <a:off x="502920" y="2724912"/>
-            <a:ext cx="11185855" cy="320040"/>
-          </a:xfrm>
-          <a:prstGeom prst="rect">
-            <a:avLst/>
-          </a:prstGeom>
-          <a:noFill/>
-        </p:spPr>
-        <p:txBody>
-          <a:bodyPr wrap="square" lIns="0" tIns="0" bIns="0">
-            <a:spAutoFit/>
-          </a:bodyPr>
-          <a:lstStyle/>
-          <a:p>
-            <a:r>
-              <a:rPr sz="1500">
-                <a:solidFill>
-                  <a:srgbClr val="0F4C81"/>
-                </a:solidFill>
-                <a:latin typeface="Noto Sans CJK KR"/>
-              </a:rPr>
-              <a:t>● </a:t>
-            </a:r>
-            <a:r>
-              <a:rPr sz="1500" b="1">
-                <a:solidFill>
-                  <a:srgbClr val="222222"/>
-                </a:solidFill>
-                <a:latin typeface="Noto Sans CJK KR"/>
-              </a:rPr>
-              <a:t>결론: 이건 정확히 프로젝트가 배치 트랙에서 이미 검증한 carve loss(exp38~44d2, 먼지 -83~93%)가 타겟하는 문제 그 자체</a:t>
-            </a:r>
-          </a:p>
-        </p:txBody>
-      </p:sp>
-      <p:sp>
-        <p:nvSpPr>
-          <p:cNvPr id="8" name="Rectangle 7"/>
-          <p:cNvSpPr/>
-          <p:nvPr/>
-        </p:nvSpPr>
-        <p:spPr>
-          <a:xfrm>
-            <a:off x="502920" y="3099816"/>
             <a:ext cx="11185855" cy="457200"/>
           </a:xfrm>
           <a:prstGeom prst="rect">
@@ -8079,7 +7566,7 @@
                 </a:solidFill>
                 <a:latin typeface="Noto Sans CJK KR"/>
               </a:rPr>
-              <a:t>최악 뷰 GT vs render 나란히 비교(바늘형 아티팩트 확대컷)</a:t>
+              <a:t>λ 스캔 곡선(0/0.1/0.5/1.0), dedup 전후 가우시안 수 막대</a:t>
             </a:r>
           </a:p>
         </p:txBody>
@@ -8104,14 +7591,48 @@
       <p:grpSpPr/>
       <p:sp>
         <p:nvSpPr>
-          <p:cNvPr id="2" name="Rectangle 1"/>
+          <p:cNvPr id="2" name="TextBox 1"/>
+          <p:cNvSpPr txBox="1"/>
+          <p:nvPr/>
+        </p:nvSpPr>
+        <p:spPr>
+          <a:xfrm>
+            <a:off x="502920" y="256032"/>
+            <a:ext cx="11185855" cy="731520"/>
+          </a:xfrm>
+          <a:prstGeom prst="rect">
+            <a:avLst/>
+          </a:prstGeom>
+          <a:noFill/>
+        </p:spPr>
+        <p:txBody>
+          <a:bodyPr wrap="square">
+            <a:spAutoFit/>
+          </a:bodyPr>
+          <a:lstStyle/>
+          <a:p>
+            <a:r>
+              <a:rPr sz="2400" b="1">
+                <a:solidFill>
+                  <a:srgbClr val="1A1A2E"/>
+                </a:solidFill>
+                <a:latin typeface="Noto Sans CJK KR"/>
+              </a:rPr>
+              <a:t>슬라이드 13 — exp51 축C+F: "더 넣으면 되겠지"가 틀렸다</a:t>
+            </a:r>
+          </a:p>
+        </p:txBody>
+      </p:sp>
+      <p:sp>
+        <p:nvSpPr>
+          <p:cNvPr id="3" name="Rectangle 2"/>
           <p:cNvSpPr/>
           <p:nvPr/>
         </p:nvSpPr>
         <p:spPr>
           <a:xfrm>
-            <a:off x="0" y="0"/>
-            <a:ext cx="12191695" cy="6858000"/>
+            <a:off x="502920" y="932688"/>
+            <a:ext cx="11185855" cy="31750"/>
           </a:xfrm>
           <a:prstGeom prst="rect">
             <a:avLst/>
@@ -8147,14 +7668,14 @@
       </p:sp>
       <p:sp>
         <p:nvSpPr>
-          <p:cNvPr id="3" name="TextBox 2"/>
+          <p:cNvPr id="4" name="TextBox 3"/>
           <p:cNvSpPr txBox="1"/>
           <p:nvPr/>
         </p:nvSpPr>
         <p:spPr>
           <a:xfrm>
-            <a:off x="914400" y="2743200"/>
-            <a:ext cx="10362895" cy="1371600"/>
+            <a:off x="502920" y="1051560"/>
+            <a:ext cx="11185855" cy="320040"/>
           </a:xfrm>
           <a:prstGeom prst="rect">
             <a:avLst/>
@@ -8162,20 +7683,292 @@
           <a:noFill/>
         </p:spPr>
         <p:txBody>
-          <a:bodyPr wrap="square">
+          <a:bodyPr wrap="square" lIns="0" tIns="0" bIns="0">
             <a:spAutoFit/>
           </a:bodyPr>
           <a:lstStyle/>
           <a:p>
-            <a:pPr algn="l"/>
-            <a:r>
-              <a:rPr sz="3400" b="1">
-                <a:solidFill>
-                  <a:srgbClr val="FFFFFF"/>
-                </a:solidFill>
-                <a:latin typeface="Noto Sans CJK KR"/>
-              </a:rPr>
-              <a:t>§4. 정직한 현재 위치와 다음 스텝 (슬라이드 15–18)</a:t>
+            <a:r>
+              <a:rPr sz="1500">
+                <a:solidFill>
+                  <a:srgbClr val="0F4C81"/>
+                </a:solidFill>
+                <a:latin typeface="Noto Sans CJK KR"/>
+              </a:rPr>
+              <a:t>● </a:t>
+            </a:r>
+            <a:r>
+              <a:rPr sz="1500" b="1">
+                <a:solidFill>
+                  <a:srgbClr val="222222"/>
+                </a:solidFill>
+                <a:latin typeface="Noto Sans CJK KR"/>
+              </a:rPr>
+              <a:t>축C(keyframe 밀도 2배)</a:t>
+            </a:r>
+            <a:r>
+              <a:rPr sz="1500" b="0">
+                <a:solidFill>
+                  <a:srgbClr val="222222"/>
+                </a:solidFill>
+                <a:latin typeface="Noto Sans CJK KR"/>
+              </a:rPr>
+              <a:t>: 57→113 서브청크, 고정예산·비례예산 두 방식 모두 재검증 → </a:t>
+            </a:r>
+            <a:r>
+              <a:rPr sz="1500" b="1">
+                <a:solidFill>
+                  <a:srgbClr val="222222"/>
+                </a:solidFill>
+                <a:latin typeface="Noto Sans CJK KR"/>
+              </a:rPr>
+              <a:t>25.11~25.30dB, 축A+B와 오차범위 내로 무효과</a:t>
+            </a:r>
+          </a:p>
+        </p:txBody>
+      </p:sp>
+      <p:sp>
+        <p:nvSpPr>
+          <p:cNvPr id="5" name="TextBox 4"/>
+          <p:cNvSpPr txBox="1"/>
+          <p:nvPr/>
+        </p:nvSpPr>
+        <p:spPr>
+          <a:xfrm>
+            <a:off x="502920" y="1426464"/>
+            <a:ext cx="11185855" cy="320040"/>
+          </a:xfrm>
+          <a:prstGeom prst="rect">
+            <a:avLst/>
+          </a:prstGeom>
+          <a:noFill/>
+        </p:spPr>
+        <p:txBody>
+          <a:bodyPr wrap="square" lIns="0" tIns="0" bIns="0">
+            <a:spAutoFit/>
+          </a:bodyPr>
+          <a:lstStyle/>
+          <a:p>
+            <a:r>
+              <a:rPr sz="1500">
+                <a:solidFill>
+                  <a:srgbClr val="0F4C81"/>
+                </a:solidFill>
+                <a:latin typeface="Noto Sans CJK KR"/>
+              </a:rPr>
+              <a:t>● </a:t>
+            </a:r>
+            <a:r>
+              <a:rPr sz="1500" b="1">
+                <a:solidFill>
+                  <a:srgbClr val="222222"/>
+                </a:solidFill>
+                <a:latin typeface="Noto Sans CJK KR"/>
+              </a:rPr>
+              <a:t>축F(학습 예산 3.3배, 28,581 iter)</a:t>
+            </a:r>
+            <a:r>
+              <a:rPr sz="1500" b="0">
+                <a:solidFill>
+                  <a:srgbClr val="222222"/>
+                </a:solidFill>
+                <a:latin typeface="Noto Sans CJK KR"/>
+              </a:rPr>
+              <a:t>: </a:t>
+            </a:r>
+            <a:r>
+              <a:rPr sz="1500" b="1">
+                <a:solidFill>
+                  <a:srgbClr val="222222"/>
+                </a:solidFill>
+                <a:latin typeface="Noto Sans CJK KR"/>
+              </a:rPr>
+              <a:t>25.59dB, +0.30만</a:t>
+            </a:r>
+            <a:r>
+              <a:rPr sz="1500" b="0">
+                <a:solidFill>
+                  <a:srgbClr val="222222"/>
+                </a:solidFill>
+                <a:latin typeface="Noto Sans CJK KR"/>
+              </a:rPr>
+              <a:t> — 예산을 대폭 늘려도 거의 안 움직임</a:t>
+            </a:r>
+          </a:p>
+        </p:txBody>
+      </p:sp>
+      <p:sp>
+        <p:nvSpPr>
+          <p:cNvPr id="6" name="TextBox 5"/>
+          <p:cNvSpPr txBox="1"/>
+          <p:nvPr/>
+        </p:nvSpPr>
+        <p:spPr>
+          <a:xfrm>
+            <a:off x="502920" y="1801368"/>
+            <a:ext cx="11185855" cy="320040"/>
+          </a:xfrm>
+          <a:prstGeom prst="rect">
+            <a:avLst/>
+          </a:prstGeom>
+          <a:noFill/>
+        </p:spPr>
+        <p:txBody>
+          <a:bodyPr wrap="square" lIns="0" tIns="0" bIns="0">
+            <a:spAutoFit/>
+          </a:bodyPr>
+          <a:lstStyle/>
+          <a:p>
+            <a:r>
+              <a:rPr sz="1500">
+                <a:solidFill>
+                  <a:srgbClr val="0F4C81"/>
+                </a:solidFill>
+                <a:latin typeface="Noto Sans CJK KR"/>
+              </a:rPr>
+              <a:t>● </a:t>
+            </a:r>
+            <a:r>
+              <a:rPr sz="1500" b="0">
+                <a:solidFill>
+                  <a:srgbClr val="222222"/>
+                </a:solidFill>
+                <a:latin typeface="Noto Sans CJK KR"/>
+              </a:rPr>
+              <a:t>Photo-SLAM 키프레임 샘플러 코드 직접 확인: 최근 키프레임 편향이 아니라 </a:t>
+            </a:r>
+            <a:r>
+              <a:rPr sz="1500" b="1">
+                <a:solidFill>
+                  <a:srgbClr val="222222"/>
+                </a:solidFill>
+                <a:latin typeface="Noto Sans CJK KR"/>
+              </a:rPr>
+              <a:t>등록된 전원을 균등 순환</a:t>
+            </a:r>
+            <a:r>
+              <a:rPr sz="1500" b="0">
+                <a:solidFill>
+                  <a:srgbClr val="222222"/>
+                </a:solidFill>
+                <a:latin typeface="Noto Sans CJK KR"/>
+              </a:rPr>
+              <a:t> — "재방문 편향" 가설도 기각</a:t>
+            </a:r>
+          </a:p>
+        </p:txBody>
+      </p:sp>
+      <p:sp>
+        <p:nvSpPr>
+          <p:cNvPr id="7" name="TextBox 6"/>
+          <p:cNvSpPr txBox="1"/>
+          <p:nvPr/>
+        </p:nvSpPr>
+        <p:spPr>
+          <a:xfrm>
+            <a:off x="502920" y="2176272"/>
+            <a:ext cx="11185855" cy="320040"/>
+          </a:xfrm>
+          <a:prstGeom prst="rect">
+            <a:avLst/>
+          </a:prstGeom>
+          <a:noFill/>
+        </p:spPr>
+        <p:txBody>
+          <a:bodyPr wrap="square" lIns="0" tIns="0" bIns="0">
+            <a:spAutoFit/>
+          </a:bodyPr>
+          <a:lstStyle/>
+          <a:p>
+            <a:r>
+              <a:rPr sz="1500">
+                <a:solidFill>
+                  <a:srgbClr val="0F4C81"/>
+                </a:solidFill>
+                <a:latin typeface="Noto Sans CJK KR"/>
+              </a:rPr>
+              <a:t>● </a:t>
+            </a:r>
+            <a:r>
+              <a:rPr sz="1500" b="1">
+                <a:solidFill>
+                  <a:srgbClr val="222222"/>
+                </a:solidFill>
+                <a:latin typeface="Noto Sans CJK KR"/>
+              </a:rPr>
+              <a:t>밀도·예산·재방문 편향 전부 아니라는 게 이 세 실험으로 확정</a:t>
+            </a:r>
+            <a:r>
+              <a:rPr sz="1500" b="0">
+                <a:solidFill>
+                  <a:srgbClr val="222222"/>
+                </a:solidFill>
+                <a:latin typeface="Noto Sans CJK KR"/>
+              </a:rPr>
+              <a:t> — 그럼 뭐가 문제인가?</a:t>
+            </a:r>
+          </a:p>
+        </p:txBody>
+      </p:sp>
+      <p:sp>
+        <p:nvSpPr>
+          <p:cNvPr id="8" name="Rectangle 7"/>
+          <p:cNvSpPr/>
+          <p:nvPr/>
+        </p:nvSpPr>
+        <p:spPr>
+          <a:xfrm>
+            <a:off x="502920" y="2551176"/>
+            <a:ext cx="11185855" cy="457200"/>
+          </a:xfrm>
+          <a:prstGeom prst="rect">
+            <a:avLst/>
+          </a:prstGeom>
+          <a:solidFill>
+            <a:srgbClr val="FFF6E0"/>
+          </a:solidFill>
+          <a:ln w="9525">
+            <a:solidFill>
+              <a:srgbClr val="E0C070"/>
+            </a:solidFill>
+          </a:ln>
+        </p:spPr>
+        <p:style>
+          <a:lnRef idx="1">
+            <a:schemeClr val="accent1"/>
+          </a:lnRef>
+          <a:fillRef idx="3">
+            <a:schemeClr val="accent1"/>
+          </a:fillRef>
+          <a:effectRef idx="2">
+            <a:schemeClr val="accent1"/>
+          </a:effectRef>
+          <a:fontRef idx="minor">
+            <a:schemeClr val="lt1"/>
+          </a:fontRef>
+        </p:style>
+        <p:txBody>
+          <a:bodyPr rtlCol="0" anchor="ctr" wrap="square" lIns="109728"/>
+          <a:lstStyle/>
+          <a:p>
+            <a:pPr algn="ctr"/>
+            <a:r>
+              <a:rPr b="1" sz="1100">
+                <a:solidFill>
+                  <a:srgbClr val="8A5A00"/>
+                </a:solidFill>
+                <a:latin typeface="Noto Sans CJK KR"/>
+              </a:rPr>
+              <a:t>🎨 시각자료  </a:t>
+            </a:r>
+            <a:r>
+              <a:rPr sz="1100" b="0">
+                <a:solidFill>
+                  <a:srgbClr val="8A5A00"/>
+                </a:solidFill>
+                <a:latin typeface="Noto Sans CJK KR"/>
+              </a:rPr>
+              <a:t>밀도/예산 스캔 결과 막대(전부 25dB대에 수렴)</a:t>
             </a:r>
           </a:p>
         </p:txBody>
@@ -8227,7 +8020,898 @@
                 </a:solidFill>
                 <a:latin typeface="Noto Sans CJK KR"/>
               </a:rPr>
-              <a:t>슬라이드 15 — 현재 스코어카드</a:t>
+              <a:t>슬라이드 14 — 자기수정: "배치 30.2dB가 상한"이라는 착각</a:t>
+            </a:r>
+          </a:p>
+        </p:txBody>
+      </p:sp>
+      <p:sp>
+        <p:nvSpPr>
+          <p:cNvPr id="3" name="Rectangle 2"/>
+          <p:cNvSpPr/>
+          <p:nvPr/>
+        </p:nvSpPr>
+        <p:spPr>
+          <a:xfrm>
+            <a:off x="502920" y="932688"/>
+            <a:ext cx="11185855" cy="31750"/>
+          </a:xfrm>
+          <a:prstGeom prst="rect">
+            <a:avLst/>
+          </a:prstGeom>
+          <a:solidFill>
+            <a:srgbClr val="0F4C81"/>
+          </a:solidFill>
+          <a:ln>
+            <a:noFill/>
+          </a:ln>
+        </p:spPr>
+        <p:style>
+          <a:lnRef idx="1">
+            <a:schemeClr val="accent1"/>
+          </a:lnRef>
+          <a:fillRef idx="3">
+            <a:schemeClr val="accent1"/>
+          </a:fillRef>
+          <a:effectRef idx="2">
+            <a:schemeClr val="accent1"/>
+          </a:effectRef>
+          <a:fontRef idx="minor">
+            <a:schemeClr val="lt1"/>
+          </a:fontRef>
+        </p:style>
+        <p:txBody>
+          <a:bodyPr rtlCol="0" anchor="ctr"/>
+          <a:lstStyle/>
+          <a:p>
+            <a:pPr algn="ctr"/>
+          </a:p>
+        </p:txBody>
+      </p:sp>
+      <p:sp>
+        <p:nvSpPr>
+          <p:cNvPr id="4" name="TextBox 3"/>
+          <p:cNvSpPr txBox="1"/>
+          <p:nvPr/>
+        </p:nvSpPr>
+        <p:spPr>
+          <a:xfrm>
+            <a:off x="502920" y="1051560"/>
+            <a:ext cx="11185855" cy="320040"/>
+          </a:xfrm>
+          <a:prstGeom prst="rect">
+            <a:avLst/>
+          </a:prstGeom>
+          <a:noFill/>
+        </p:spPr>
+        <p:txBody>
+          <a:bodyPr wrap="square" lIns="0" tIns="0" bIns="0">
+            <a:spAutoFit/>
+          </a:bodyPr>
+          <a:lstStyle/>
+          <a:p>
+            <a:r>
+              <a:rPr sz="1500">
+                <a:solidFill>
+                  <a:srgbClr val="0F4C81"/>
+                </a:solidFill>
+                <a:latin typeface="Noto Sans CJK KR"/>
+              </a:rPr>
+              <a:t>● </a:t>
+            </a:r>
+            <a:r>
+              <a:rPr sz="1500" b="0">
+                <a:solidFill>
+                  <a:srgbClr val="222222"/>
+                </a:solidFill>
+                <a:latin typeface="Noto Sans CJK KR"/>
+              </a:rPr>
+              <a:t>축C/F 결과를 두고 처음엔 </a:t>
+            </a:r>
+            <a:r>
+              <a:rPr sz="1500" b="1">
+                <a:solidFill>
+                  <a:srgbClr val="222222"/>
+                </a:solidFill>
+                <a:latin typeface="Noto Sans CJK KR"/>
+              </a:rPr>
+              <a:t>"장면 콘텐츠 난이도(저텍스처+specular) 때문에 30.2dB가 이 장면의 사실상 상한"</a:t>
+            </a:r>
+            <a:r>
+              <a:rPr sz="1500" b="0">
+                <a:solidFill>
+                  <a:srgbClr val="222222"/>
+                </a:solidFill>
+                <a:latin typeface="Noto Sans CJK KR"/>
+              </a:rPr>
+              <a:t>이라고 결론 내렸음</a:t>
+            </a:r>
+          </a:p>
+        </p:txBody>
+      </p:sp>
+      <p:sp>
+        <p:nvSpPr>
+          <p:cNvPr id="5" name="TextBox 4"/>
+          <p:cNvSpPr txBox="1"/>
+          <p:nvPr/>
+        </p:nvSpPr>
+        <p:spPr>
+          <a:xfrm>
+            <a:off x="502920" y="1426464"/>
+            <a:ext cx="11185855" cy="594360"/>
+          </a:xfrm>
+          <a:prstGeom prst="rect">
+            <a:avLst/>
+          </a:prstGeom>
+          <a:noFill/>
+        </p:spPr>
+        <p:txBody>
+          <a:bodyPr wrap="square" lIns="0" tIns="0" bIns="0">
+            <a:spAutoFit/>
+          </a:bodyPr>
+          <a:lstStyle/>
+          <a:p>
+            <a:r>
+              <a:rPr sz="1500">
+                <a:solidFill>
+                  <a:srgbClr val="0F4C81"/>
+                </a:solidFill>
+                <a:latin typeface="Noto Sans CJK KR"/>
+              </a:rPr>
+              <a:t>● </a:t>
+            </a:r>
+            <a:r>
+              <a:rPr sz="1500" b="1">
+                <a:solidFill>
+                  <a:srgbClr val="222222"/>
+                </a:solidFill>
+                <a:latin typeface="Noto Sans CJK KR"/>
+              </a:rPr>
+              <a:t>사용자 지적("일반 3dgs로 33 나왔었는데")으로 발견</a:t>
+            </a:r>
+            <a:r>
+              <a:rPr sz="1500" b="0">
+                <a:solidFill>
+                  <a:srgbClr val="222222"/>
+                </a:solidFill>
+                <a:latin typeface="Noto Sans CJK KR"/>
+              </a:rPr>
+              <a:t>: 30.2dB는 exp48 시절 </a:t>
+            </a:r>
+            <a:r>
+              <a:rPr sz="1500" b="1">
+                <a:solidFill>
+                  <a:srgbClr val="222222"/>
+                </a:solidFill>
+                <a:latin typeface="Noto Sans CJK KR"/>
+              </a:rPr>
+              <a:t>8,550 iteration으로 예산을 캡 씌운 통제실험</a:t>
+            </a:r>
+            <a:r>
+              <a:rPr sz="1500" b="0">
+                <a:solidFill>
+                  <a:srgbClr val="222222"/>
+                </a:solidFill>
+                <a:latin typeface="Noto Sans CJK KR"/>
+              </a:rPr>
+              <a:t> 수치였을 뿐, 진짜 배치 상한이 아니었음</a:t>
+            </a:r>
+          </a:p>
+        </p:txBody>
+      </p:sp>
+      <p:sp>
+        <p:nvSpPr>
+          <p:cNvPr id="6" name="TextBox 5"/>
+          <p:cNvSpPr txBox="1"/>
+          <p:nvPr/>
+        </p:nvSpPr>
+        <p:spPr>
+          <a:xfrm>
+            <a:off x="502920" y="2075688"/>
+            <a:ext cx="11185855" cy="594360"/>
+          </a:xfrm>
+          <a:prstGeom prst="rect">
+            <a:avLst/>
+          </a:prstGeom>
+          <a:noFill/>
+        </p:spPr>
+        <p:txBody>
+          <a:bodyPr wrap="square" lIns="0" tIns="0" bIns="0">
+            <a:spAutoFit/>
+          </a:bodyPr>
+          <a:lstStyle/>
+          <a:p>
+            <a:r>
+              <a:rPr sz="1500">
+                <a:solidFill>
+                  <a:srgbClr val="0F4C81"/>
+                </a:solidFill>
+                <a:latin typeface="Noto Sans CJK KR"/>
+              </a:rPr>
+              <a:t>● </a:t>
+            </a:r>
+            <a:r>
+              <a:rPr sz="1500" b="0">
+                <a:solidFill>
+                  <a:srgbClr val="222222"/>
+                </a:solidFill>
+                <a:latin typeface="Noto Sans CJK KR"/>
+              </a:rPr>
+              <a:t>같은 장면의 </a:t>
+            </a:r>
+            <a:r>
+              <a:rPr sz="1500" b="1">
+                <a:solidFill>
+                  <a:srgbClr val="222222"/>
+                </a:solidFill>
+                <a:latin typeface="Noto Sans CJK KR"/>
+              </a:rPr>
+              <a:t>진짜 풀 30k-iteration 배치 결과</a:t>
+            </a:r>
+            <a:r>
+              <a:rPr sz="1500" b="0">
+                <a:solidFill>
+                  <a:srgbClr val="222222"/>
+                </a:solidFill>
+                <a:latin typeface="Noto Sans CJK KR"/>
+              </a:rPr>
+              <a:t>(exp44_fast_geometry_plan.md에 이미 있었음): baseline(ORB init) test </a:t>
+            </a:r>
+            <a:r>
+              <a:rPr sz="1500" b="1">
+                <a:solidFill>
+                  <a:srgbClr val="222222"/>
+                </a:solidFill>
+                <a:latin typeface="Noto Sans CJK KR"/>
+              </a:rPr>
+              <a:t>31.549dB</a:t>
+            </a:r>
+            <a:r>
+              <a:rPr sz="1500" b="0">
+                <a:solidFill>
+                  <a:srgbClr val="222222"/>
+                </a:solidFill>
+                <a:latin typeface="Noto Sans CJK KR"/>
+              </a:rPr>
+              <a:t>, 챔피언(hybrid init+carve) test </a:t>
+            </a:r>
+            <a:r>
+              <a:rPr sz="1500" b="1">
+                <a:solidFill>
+                  <a:srgbClr val="222222"/>
+                </a:solidFill>
+                <a:latin typeface="Noto Sans CJK KR"/>
+              </a:rPr>
+              <a:t>32.479dB / train 33.799dB</a:t>
+            </a:r>
+          </a:p>
+        </p:txBody>
+      </p:sp>
+      <p:sp>
+        <p:nvSpPr>
+          <p:cNvPr id="7" name="TextBox 6"/>
+          <p:cNvSpPr txBox="1"/>
+          <p:nvPr/>
+        </p:nvSpPr>
+        <p:spPr>
+          <a:xfrm>
+            <a:off x="502920" y="2724912"/>
+            <a:ext cx="11185855" cy="320040"/>
+          </a:xfrm>
+          <a:prstGeom prst="rect">
+            <a:avLst/>
+          </a:prstGeom>
+          <a:noFill/>
+        </p:spPr>
+        <p:txBody>
+          <a:bodyPr wrap="square" lIns="0" tIns="0" bIns="0">
+            <a:spAutoFit/>
+          </a:bodyPr>
+          <a:lstStyle/>
+          <a:p>
+            <a:r>
+              <a:rPr sz="1500">
+                <a:solidFill>
+                  <a:srgbClr val="0F4C81"/>
+                </a:solidFill>
+                <a:latin typeface="Noto Sans CJK KR"/>
+              </a:rPr>
+              <a:t>● </a:t>
+            </a:r>
+            <a:r>
+              <a:rPr sz="1500" b="0">
+                <a:solidFill>
+                  <a:srgbClr val="222222"/>
+                </a:solidFill>
+                <a:latin typeface="Noto Sans CJK KR"/>
+              </a:rPr>
+              <a:t>축A~F는 전부 8,550~28,581 iteration — 배치 30k에 못 미치는 캡 안에서 실험한 것이었음</a:t>
+            </a:r>
+          </a:p>
+        </p:txBody>
+      </p:sp>
+      <p:sp>
+        <p:nvSpPr>
+          <p:cNvPr id="8" name="Rectangle 7"/>
+          <p:cNvSpPr/>
+          <p:nvPr/>
+        </p:nvSpPr>
+        <p:spPr>
+          <a:xfrm>
+            <a:off x="502920" y="3099816"/>
+            <a:ext cx="11185855" cy="457200"/>
+          </a:xfrm>
+          <a:prstGeom prst="rect">
+            <a:avLst/>
+          </a:prstGeom>
+          <a:solidFill>
+            <a:srgbClr val="FFF6E0"/>
+          </a:solidFill>
+          <a:ln w="9525">
+            <a:solidFill>
+              <a:srgbClr val="E0C070"/>
+            </a:solidFill>
+          </a:ln>
+        </p:spPr>
+        <p:style>
+          <a:lnRef idx="1">
+            <a:schemeClr val="accent1"/>
+          </a:lnRef>
+          <a:fillRef idx="3">
+            <a:schemeClr val="accent1"/>
+          </a:fillRef>
+          <a:effectRef idx="2">
+            <a:schemeClr val="accent1"/>
+          </a:effectRef>
+          <a:fontRef idx="minor">
+            <a:schemeClr val="lt1"/>
+          </a:fontRef>
+        </p:style>
+        <p:txBody>
+          <a:bodyPr rtlCol="0" anchor="ctr" wrap="square" lIns="109728"/>
+          <a:lstStyle/>
+          <a:p>
+            <a:pPr algn="ctr"/>
+            <a:r>
+              <a:rPr b="1" sz="1100">
+                <a:solidFill>
+                  <a:srgbClr val="8A5A00"/>
+                </a:solidFill>
+                <a:latin typeface="Noto Sans CJK KR"/>
+              </a:rPr>
+              <a:t>🎨 시각자료  </a:t>
+            </a:r>
+            <a:r>
+              <a:rPr sz="1100" b="0">
+                <a:solidFill>
+                  <a:srgbClr val="8A5A00"/>
+                </a:solidFill>
+                <a:latin typeface="Noto Sans CJK KR"/>
+              </a:rPr>
+              <a:t>"30.2dB(가짜 상한) vs 31.5~32.5dB(진짜 상한)" 정정 막대</a:t>
+            </a:r>
+          </a:p>
+        </p:txBody>
+      </p:sp>
+    </p:spTree>
+  </p:cSld>
+  <p:clrMapOvr>
+    <a:masterClrMapping/>
+  </p:clrMapOvr>
+</p:sld>
+</file>
+
+<file path=ppt/slides/slide23.xml><?xml version="1.0" encoding="utf-8"?>
+<p:sld xmlns:a="http://schemas.openxmlformats.org/drawingml/2006/main" xmlns:p="http://schemas.openxmlformats.org/presentationml/2006/main" xmlns:r="http://schemas.openxmlformats.org/officeDocument/2006/relationships">
+  <p:cSld>
+    <p:spTree>
+      <p:nvGrpSpPr>
+        <p:cNvPr id="1" name=""/>
+        <p:cNvGrpSpPr/>
+        <p:nvPr/>
+      </p:nvGrpSpPr>
+      <p:grpSpPr/>
+      <p:sp>
+        <p:nvSpPr>
+          <p:cNvPr id="2" name="TextBox 1"/>
+          <p:cNvSpPr txBox="1"/>
+          <p:nvPr/>
+        </p:nvSpPr>
+        <p:spPr>
+          <a:xfrm>
+            <a:off x="502920" y="256032"/>
+            <a:ext cx="11185855" cy="731520"/>
+          </a:xfrm>
+          <a:prstGeom prst="rect">
+            <a:avLst/>
+          </a:prstGeom>
+          <a:noFill/>
+        </p:spPr>
+        <p:txBody>
+          <a:bodyPr wrap="square">
+            <a:spAutoFit/>
+          </a:bodyPr>
+          <a:lstStyle/>
+          <a:p>
+            <a:r>
+              <a:rPr sz="2400" b="1">
+                <a:solidFill>
+                  <a:srgbClr val="1A1A2E"/>
+                </a:solidFill>
+                <a:latin typeface="Noto Sans CJK KR"/>
+              </a:rPr>
+              <a:t>슬라이드 15 — 시각 진단 확정: 잔여 갭의 정체는 depth-init 바늘형 floater</a:t>
+            </a:r>
+          </a:p>
+        </p:txBody>
+      </p:sp>
+      <p:sp>
+        <p:nvSpPr>
+          <p:cNvPr id="3" name="Rectangle 2"/>
+          <p:cNvSpPr/>
+          <p:nvPr/>
+        </p:nvSpPr>
+        <p:spPr>
+          <a:xfrm>
+            <a:off x="502920" y="932688"/>
+            <a:ext cx="11185855" cy="31750"/>
+          </a:xfrm>
+          <a:prstGeom prst="rect">
+            <a:avLst/>
+          </a:prstGeom>
+          <a:solidFill>
+            <a:srgbClr val="0F4C81"/>
+          </a:solidFill>
+          <a:ln>
+            <a:noFill/>
+          </a:ln>
+        </p:spPr>
+        <p:style>
+          <a:lnRef idx="1">
+            <a:schemeClr val="accent1"/>
+          </a:lnRef>
+          <a:fillRef idx="3">
+            <a:schemeClr val="accent1"/>
+          </a:fillRef>
+          <a:effectRef idx="2">
+            <a:schemeClr val="accent1"/>
+          </a:effectRef>
+          <a:fontRef idx="minor">
+            <a:schemeClr val="lt1"/>
+          </a:fontRef>
+        </p:style>
+        <p:txBody>
+          <a:bodyPr rtlCol="0" anchor="ctr"/>
+          <a:lstStyle/>
+          <a:p>
+            <a:pPr algn="ctr"/>
+          </a:p>
+        </p:txBody>
+      </p:sp>
+      <p:sp>
+        <p:nvSpPr>
+          <p:cNvPr id="4" name="TextBox 3"/>
+          <p:cNvSpPr txBox="1"/>
+          <p:nvPr/>
+        </p:nvSpPr>
+        <p:spPr>
+          <a:xfrm>
+            <a:off x="502920" y="1051560"/>
+            <a:ext cx="11185855" cy="320040"/>
+          </a:xfrm>
+          <a:prstGeom prst="rect">
+            <a:avLst/>
+          </a:prstGeom>
+          <a:noFill/>
+        </p:spPr>
+        <p:txBody>
+          <a:bodyPr wrap="square" lIns="0" tIns="0" bIns="0">
+            <a:spAutoFit/>
+          </a:bodyPr>
+          <a:lstStyle/>
+          <a:p>
+            <a:r>
+              <a:rPr sz="1500">
+                <a:solidFill>
+                  <a:srgbClr val="0F4C81"/>
+                </a:solidFill>
+                <a:latin typeface="Noto Sans CJK KR"/>
+              </a:rPr>
+              <a:t>● </a:t>
+            </a:r>
+            <a:r>
+              <a:rPr sz="1500" b="0">
+                <a:solidFill>
+                  <a:srgbClr val="222222"/>
+                </a:solidFill>
+                <a:latin typeface="Noto Sans CJK KR"/>
+              </a:rPr>
+              <a:t>정정된 상한(31.5~32.5dB)으로 다시 보면 축F(25.59dB)도 여전히 6~7dB 갭 — 밀도·예산·편향 다 아니라면 남은 후보는?</a:t>
+            </a:r>
+          </a:p>
+        </p:txBody>
+      </p:sp>
+      <p:sp>
+        <p:nvSpPr>
+          <p:cNvPr id="5" name="TextBox 4"/>
+          <p:cNvSpPr txBox="1"/>
+          <p:nvPr/>
+        </p:nvSpPr>
+        <p:spPr>
+          <a:xfrm>
+            <a:off x="502920" y="1426464"/>
+            <a:ext cx="11185855" cy="594360"/>
+          </a:xfrm>
+          <a:prstGeom prst="rect">
+            <a:avLst/>
+          </a:prstGeom>
+          <a:noFill/>
+        </p:spPr>
+        <p:txBody>
+          <a:bodyPr wrap="square" lIns="0" tIns="0" bIns="0">
+            <a:spAutoFit/>
+          </a:bodyPr>
+          <a:lstStyle/>
+          <a:p>
+            <a:r>
+              <a:rPr sz="1500">
+                <a:solidFill>
+                  <a:srgbClr val="0F4C81"/>
+                </a:solidFill>
+                <a:latin typeface="Noto Sans CJK KR"/>
+              </a:rPr>
+              <a:t>● </a:t>
+            </a:r>
+            <a:r>
+              <a:rPr sz="1500" b="1">
+                <a:solidFill>
+                  <a:srgbClr val="222222"/>
+                </a:solidFill>
+                <a:latin typeface="Noto Sans CJK KR"/>
+              </a:rPr>
+              <a:t>최악 held-out 뷰(화이트보드+문 장면)의 GT/render를 직접 육안 대조</a:t>
+            </a:r>
+            <a:r>
+              <a:rPr sz="1500" b="0">
+                <a:solidFill>
+                  <a:srgbClr val="222222"/>
+                </a:solidFill>
+                <a:latin typeface="Noto Sans CJK KR"/>
+              </a:rPr>
+              <a:t>: GT는 평범한 실내 장면인데 </a:t>
+            </a:r>
+            <a:r>
+              <a:rPr sz="1500" b="1">
+                <a:solidFill>
+                  <a:srgbClr val="222222"/>
+                </a:solidFill>
+                <a:latin typeface="Noto Sans CJK KR"/>
+              </a:rPr>
+              <a:t>render는 화면 전체가 바늘형(needle) floater 아티팩트로 뒤덮임</a:t>
+            </a:r>
+            <a:r>
+              <a:rPr sz="1500" b="0">
+                <a:solidFill>
+                  <a:srgbClr val="222222"/>
+                </a:solidFill>
+                <a:latin typeface="Noto Sans CJK KR"/>
+              </a:rPr>
+              <a:t> — "블러/저화질"이 아니라 명백한 floater 문제</a:t>
+            </a:r>
+          </a:p>
+        </p:txBody>
+      </p:sp>
+      <p:sp>
+        <p:nvSpPr>
+          <p:cNvPr id="6" name="TextBox 5"/>
+          <p:cNvSpPr txBox="1"/>
+          <p:nvPr/>
+        </p:nvSpPr>
+        <p:spPr>
+          <a:xfrm>
+            <a:off x="502920" y="2075688"/>
+            <a:ext cx="11185855" cy="594360"/>
+          </a:xfrm>
+          <a:prstGeom prst="rect">
+            <a:avLst/>
+          </a:prstGeom>
+          <a:noFill/>
+        </p:spPr>
+        <p:txBody>
+          <a:bodyPr wrap="square" lIns="0" tIns="0" bIns="0">
+            <a:spAutoFit/>
+          </a:bodyPr>
+          <a:lstStyle/>
+          <a:p>
+            <a:r>
+              <a:rPr sz="1500">
+                <a:solidFill>
+                  <a:srgbClr val="0F4C81"/>
+                </a:solidFill>
+                <a:latin typeface="Noto Sans CJK KR"/>
+              </a:rPr>
+              <a:t>● </a:t>
+            </a:r>
+            <a:r>
+              <a:rPr sz="1500" b="0">
+                <a:solidFill>
+                  <a:srgbClr val="222222"/>
+                </a:solidFill>
+                <a:latin typeface="Noto Sans CJK KR"/>
+              </a:rPr>
+              <a:t>원인 가설: keyframe마다 </a:t>
+            </a:r>
+            <a:r>
+              <a:rPr sz="1500" b="1">
+                <a:solidFill>
+                  <a:srgbClr val="222222"/>
+                </a:solidFill>
+                <a:latin typeface="Noto Sans CJK KR"/>
+              </a:rPr>
+              <a:t>자기 단일 시점 depth-pro 추정치 하나로만 init</a:t>
+            </a:r>
+            <a:r>
+              <a:rPr sz="1500" b="0">
+                <a:solidFill>
+                  <a:srgbClr val="222222"/>
+                </a:solidFill>
+                <a:latin typeface="Noto Sans CJK KR"/>
+              </a:rPr>
+              <a:t>되어 specular/저텍스처 구간에서 처음부터 잘못 앵커링되고, 배치처럼 겹치는 여러 시점이 교차검증할 기회가 없어 안 고쳐짐</a:t>
+            </a:r>
+          </a:p>
+        </p:txBody>
+      </p:sp>
+      <p:sp>
+        <p:nvSpPr>
+          <p:cNvPr id="7" name="TextBox 6"/>
+          <p:cNvSpPr txBox="1"/>
+          <p:nvPr/>
+        </p:nvSpPr>
+        <p:spPr>
+          <a:xfrm>
+            <a:off x="502920" y="2724912"/>
+            <a:ext cx="11185855" cy="320040"/>
+          </a:xfrm>
+          <a:prstGeom prst="rect">
+            <a:avLst/>
+          </a:prstGeom>
+          <a:noFill/>
+        </p:spPr>
+        <p:txBody>
+          <a:bodyPr wrap="square" lIns="0" tIns="0" bIns="0">
+            <a:spAutoFit/>
+          </a:bodyPr>
+          <a:lstStyle/>
+          <a:p>
+            <a:r>
+              <a:rPr sz="1500">
+                <a:solidFill>
+                  <a:srgbClr val="0F4C81"/>
+                </a:solidFill>
+                <a:latin typeface="Noto Sans CJK KR"/>
+              </a:rPr>
+              <a:t>● </a:t>
+            </a:r>
+            <a:r>
+              <a:rPr sz="1500" b="1">
+                <a:solidFill>
+                  <a:srgbClr val="222222"/>
+                </a:solidFill>
+                <a:latin typeface="Noto Sans CJK KR"/>
+              </a:rPr>
+              <a:t>결론: 이건 정확히 프로젝트가 배치 트랙에서 이미 검증한 carve loss(exp38~44d2, 먼지 -83~93%)가 타겟하는 문제 그 자체</a:t>
+            </a:r>
+          </a:p>
+        </p:txBody>
+      </p:sp>
+      <p:sp>
+        <p:nvSpPr>
+          <p:cNvPr id="8" name="Rectangle 7"/>
+          <p:cNvSpPr/>
+          <p:nvPr/>
+        </p:nvSpPr>
+        <p:spPr>
+          <a:xfrm>
+            <a:off x="502920" y="3099816"/>
+            <a:ext cx="11185855" cy="457200"/>
+          </a:xfrm>
+          <a:prstGeom prst="rect">
+            <a:avLst/>
+          </a:prstGeom>
+          <a:solidFill>
+            <a:srgbClr val="FFF6E0"/>
+          </a:solidFill>
+          <a:ln w="9525">
+            <a:solidFill>
+              <a:srgbClr val="E0C070"/>
+            </a:solidFill>
+          </a:ln>
+        </p:spPr>
+        <p:style>
+          <a:lnRef idx="1">
+            <a:schemeClr val="accent1"/>
+          </a:lnRef>
+          <a:fillRef idx="3">
+            <a:schemeClr val="accent1"/>
+          </a:fillRef>
+          <a:effectRef idx="2">
+            <a:schemeClr val="accent1"/>
+          </a:effectRef>
+          <a:fontRef idx="minor">
+            <a:schemeClr val="lt1"/>
+          </a:fontRef>
+        </p:style>
+        <p:txBody>
+          <a:bodyPr rtlCol="0" anchor="ctr" wrap="square" lIns="109728"/>
+          <a:lstStyle/>
+          <a:p>
+            <a:pPr algn="ctr"/>
+            <a:r>
+              <a:rPr b="1" sz="1100">
+                <a:solidFill>
+                  <a:srgbClr val="8A5A00"/>
+                </a:solidFill>
+                <a:latin typeface="Noto Sans CJK KR"/>
+              </a:rPr>
+              <a:t>🎨 시각자료  </a:t>
+            </a:r>
+            <a:r>
+              <a:rPr sz="1100" b="0">
+                <a:solidFill>
+                  <a:srgbClr val="8A5A00"/>
+                </a:solidFill>
+                <a:latin typeface="Noto Sans CJK KR"/>
+              </a:rPr>
+              <a:t>최악 뷰 GT vs render 나란히 비교(바늘형 아티팩트 확대컷)</a:t>
+            </a:r>
+          </a:p>
+        </p:txBody>
+      </p:sp>
+    </p:spTree>
+  </p:cSld>
+  <p:clrMapOvr>
+    <a:masterClrMapping/>
+  </p:clrMapOvr>
+</p:sld>
+</file>
+
+<file path=ppt/slides/slide24.xml><?xml version="1.0" encoding="utf-8"?>
+<p:sld xmlns:a="http://schemas.openxmlformats.org/drawingml/2006/main" xmlns:p="http://schemas.openxmlformats.org/presentationml/2006/main" xmlns:r="http://schemas.openxmlformats.org/officeDocument/2006/relationships">
+  <p:cSld>
+    <p:spTree>
+      <p:nvGrpSpPr>
+        <p:cNvPr id="1" name=""/>
+        <p:cNvGrpSpPr/>
+        <p:nvPr/>
+      </p:nvGrpSpPr>
+      <p:grpSpPr/>
+      <p:sp>
+        <p:nvSpPr>
+          <p:cNvPr id="2" name="Rectangle 1"/>
+          <p:cNvSpPr/>
+          <p:nvPr/>
+        </p:nvSpPr>
+        <p:spPr>
+          <a:xfrm>
+            <a:off x="0" y="0"/>
+            <a:ext cx="12191695" cy="6858000"/>
+          </a:xfrm>
+          <a:prstGeom prst="rect">
+            <a:avLst/>
+          </a:prstGeom>
+          <a:solidFill>
+            <a:srgbClr val="0F4C81"/>
+          </a:solidFill>
+          <a:ln>
+            <a:noFill/>
+          </a:ln>
+        </p:spPr>
+        <p:style>
+          <a:lnRef idx="1">
+            <a:schemeClr val="accent1"/>
+          </a:lnRef>
+          <a:fillRef idx="3">
+            <a:schemeClr val="accent1"/>
+          </a:fillRef>
+          <a:effectRef idx="2">
+            <a:schemeClr val="accent1"/>
+          </a:effectRef>
+          <a:fontRef idx="minor">
+            <a:schemeClr val="lt1"/>
+          </a:fontRef>
+        </p:style>
+        <p:txBody>
+          <a:bodyPr rtlCol="0" anchor="ctr"/>
+          <a:lstStyle/>
+          <a:p>
+            <a:pPr algn="ctr"/>
+          </a:p>
+        </p:txBody>
+      </p:sp>
+      <p:sp>
+        <p:nvSpPr>
+          <p:cNvPr id="3" name="TextBox 2"/>
+          <p:cNvSpPr txBox="1"/>
+          <p:nvPr/>
+        </p:nvSpPr>
+        <p:spPr>
+          <a:xfrm>
+            <a:off x="914400" y="2743200"/>
+            <a:ext cx="10362895" cy="1371600"/>
+          </a:xfrm>
+          <a:prstGeom prst="rect">
+            <a:avLst/>
+          </a:prstGeom>
+          <a:noFill/>
+        </p:spPr>
+        <p:txBody>
+          <a:bodyPr wrap="square">
+            <a:spAutoFit/>
+          </a:bodyPr>
+          <a:lstStyle/>
+          <a:p>
+            <a:pPr algn="l"/>
+            <a:r>
+              <a:rPr sz="3400" b="1">
+                <a:solidFill>
+                  <a:srgbClr val="FFFFFF"/>
+                </a:solidFill>
+                <a:latin typeface="Noto Sans CJK KR"/>
+              </a:rPr>
+              <a:t>§4. 정직한 현재 위치와 다음 스텝 (슬라이드 16–19)</a:t>
+            </a:r>
+          </a:p>
+        </p:txBody>
+      </p:sp>
+    </p:spTree>
+  </p:cSld>
+  <p:clrMapOvr>
+    <a:masterClrMapping/>
+  </p:clrMapOvr>
+</p:sld>
+</file>
+
+<file path=ppt/slides/slide25.xml><?xml version="1.0" encoding="utf-8"?>
+<p:sld xmlns:a="http://schemas.openxmlformats.org/drawingml/2006/main" xmlns:p="http://schemas.openxmlformats.org/presentationml/2006/main" xmlns:r="http://schemas.openxmlformats.org/officeDocument/2006/relationships">
+  <p:cSld>
+    <p:spTree>
+      <p:nvGrpSpPr>
+        <p:cNvPr id="1" name=""/>
+        <p:cNvGrpSpPr/>
+        <p:nvPr/>
+      </p:nvGrpSpPr>
+      <p:grpSpPr/>
+      <p:sp>
+        <p:nvSpPr>
+          <p:cNvPr id="2" name="TextBox 1"/>
+          <p:cNvSpPr txBox="1"/>
+          <p:nvPr/>
+        </p:nvSpPr>
+        <p:spPr>
+          <a:xfrm>
+            <a:off x="502920" y="256032"/>
+            <a:ext cx="11185855" cy="731520"/>
+          </a:xfrm>
+          <a:prstGeom prst="rect">
+            <a:avLst/>
+          </a:prstGeom>
+          <a:noFill/>
+        </p:spPr>
+        <p:txBody>
+          <a:bodyPr wrap="square">
+            <a:spAutoFit/>
+          </a:bodyPr>
+          <a:lstStyle/>
+          <a:p>
+            <a:r>
+              <a:rPr sz="2400" b="1">
+                <a:solidFill>
+                  <a:srgbClr val="1A1A2E"/>
+                </a:solidFill>
+                <a:latin typeface="Noto Sans CJK KR"/>
+              </a:rPr>
+              <a:t>슬라이드 16 — 현재 스코어카드</a:t>
             </a:r>
           </a:p>
         </p:txBody>
@@ -8774,7 +9458,7 @@
 </p:sld>
 </file>
 
-<file path=ppt/slides/slide23.xml><?xml version="1.0" encoding="utf-8"?>
+<file path=ppt/slides/slide26.xml><?xml version="1.0" encoding="utf-8"?>
 <p:sld xmlns:a="http://schemas.openxmlformats.org/drawingml/2006/main" xmlns:p="http://schemas.openxmlformats.org/presentationml/2006/main" xmlns:r="http://schemas.openxmlformats.org/officeDocument/2006/relationships">
   <p:cSld>
     <p:spTree>
@@ -8813,7 +9497,7 @@
                 </a:solidFill>
                 <a:latin typeface="Noto Sans CJK KR"/>
               </a:rPr>
-              <a:t>슬라이드 16 — 진행 중 걸림돌: 전체 프레임+vanilla급 예산 실험이 CUDA OOM</a:t>
+              <a:t>슬라이드 17 — 진행 중 걸림돌: 전체 프레임+vanilla급 예산 실험이 CUDA OOM</a:t>
             </a:r>
           </a:p>
         </p:txBody>
@@ -9201,7 +9885,7 @@
 </p:sld>
 </file>
 
-<file path=ppt/slides/slide24.xml><?xml version="1.0" encoding="utf-8"?>
+<file path=ppt/slides/slide27.xml><?xml version="1.0" encoding="utf-8"?>
 <p:sld xmlns:a="http://schemas.openxmlformats.org/drawingml/2006/main" xmlns:p="http://schemas.openxmlformats.org/presentationml/2006/main" xmlns:r="http://schemas.openxmlformats.org/officeDocument/2006/relationships">
   <p:cSld>
     <p:spTree>
@@ -9240,7 +9924,7 @@
                 </a:solidFill>
                 <a:latin typeface="Noto Sans CJK KR"/>
               </a:rPr>
-              <a:t>슬라이드 17 — 다음 스텝: 축E — 검증된 Carve Loss를 Incremental에 이식</a:t>
+              <a:t>슬라이드 18 — 다음 스텝: 축E — 검증된 Carve Loss를 Incremental에 이식</a:t>
             </a:r>
           </a:p>
         </p:txBody>
@@ -9497,7 +10181,7 @@
 </p:sld>
 </file>
 
-<file path=ppt/slides/slide25.xml><?xml version="1.0" encoding="utf-8"?>
+<file path=ppt/slides/slide28.xml><?xml version="1.0" encoding="utf-8"?>
 <p:sld xmlns:a="http://schemas.openxmlformats.org/drawingml/2006/main" xmlns:p="http://schemas.openxmlformats.org/presentationml/2006/main" xmlns:r="http://schemas.openxmlformats.org/officeDocument/2006/relationships">
   <p:cSld>
     <p:spTree>
@@ -9536,7 +10220,7 @@
                 </a:solidFill>
                 <a:latin typeface="Noto Sans CJK KR"/>
               </a:rPr>
-              <a:t>슬라이드 18 — 결론 한 줄</a:t>
+              <a:t>슬라이드 19 — 결론 한 줄</a:t>
             </a:r>
           </a:p>
         </p:txBody>
@@ -10775,7 +11459,7 @@
                 </a:solidFill>
                 <a:latin typeface="Noto Sans CJK KR"/>
               </a:rPr>
-              <a:t>§1. 배치 트랙 마무리 (슬라이드 4–5)</a:t>
+              <a:t>§1. 배치 트랙 마무리 (슬라이드 4–6)</a:t>
             </a:r>
           </a:p>
         </p:txBody>
@@ -11451,7 +12135,7 @@
                 </a:solidFill>
                 <a:latin typeface="Noto Sans CJK KR"/>
               </a:rPr>
-              <a:t>슬라이드 5 — exp47: 속도 트랙 — 배치 트랙 실질 종료</a:t>
+              <a:t>슬라이드 5 — Init 레시피 상세: 어떤 anchor로 만들었나</a:t>
             </a:r>
           </a:p>
         </p:txBody>
@@ -11508,7 +12192,7 @@
         <p:spPr>
           <a:xfrm>
             <a:off x="502920" y="1051560"/>
-            <a:ext cx="11185855" cy="320040"/>
+            <a:ext cx="11185855" cy="594360"/>
           </a:xfrm>
           <a:prstGeom prst="rect">
             <a:avLst/>
@@ -11537,25 +12221,25 @@
                 </a:solidFill>
                 <a:latin typeface="Noto Sans CJK KR"/>
               </a:rPr>
-              <a:t>S2(cheapcarve): </a:t>
-            </a:r>
-            <a:r>
-              <a:rPr sz="1500" b="1">
-                <a:solidFill>
-                  <a:srgbClr val="222222"/>
-                </a:solidFill>
-                <a:latin typeface="Noto Sans CJK KR"/>
-              </a:rPr>
-              <a:t>화질 무손실(35.116dB) + 시간 60% 단축(26.8분)</a:t>
+              <a:t>슬라이드4의 "hybrid init"이 뭉뚱그려진 표현이 되지 않도록 — 실제로 어떤 재료·anchor로 만들어졌는지 정확히(</a:t>
             </a:r>
             <a:r>
               <a:rPr sz="1500" b="0">
                 <a:solidFill>
                   <a:srgbClr val="222222"/>
                 </a:solidFill>
-                <a:latin typeface="Noto Sans CJK KR"/>
-              </a:rPr>
-              <a:t> — 최대 성과</a:t>
+                <a:latin typeface="Noto Sans Mono CJK KR"/>
+              </a:rPr>
+              <a:t>scripts/anchors/build_hybrid_init_scene.py</a:t>
+            </a:r>
+            <a:r>
+              <a:rPr sz="1500" b="0">
+                <a:solidFill>
+                  <a:srgbClr val="222222"/>
+                </a:solidFill>
+                <a:latin typeface="Noto Sans CJK KR"/>
+              </a:rPr>
+              <a:t>)</a:t>
             </a:r>
           </a:p>
         </p:txBody>
@@ -11568,7 +12252,7 @@
         </p:nvSpPr>
         <p:spPr>
           <a:xfrm>
-            <a:off x="502920" y="1426464"/>
+            <a:off x="502920" y="1700784"/>
             <a:ext cx="11185855" cy="320040"/>
           </a:xfrm>
           <a:prstGeom prst="rect">
@@ -11592,13 +12276,22 @@
               <a:t>● </a:t>
             </a:r>
             <a:r>
+              <a:rPr sz="1500" b="1">
+                <a:solidFill>
+                  <a:srgbClr val="222222"/>
+                </a:solidFill>
+                <a:latin typeface="Noto Sans CJK KR"/>
+              </a:rPr>
+              <a:t>재료 3종 생성</a:t>
+            </a:r>
+            <a:r>
               <a:rPr sz="1500" b="0">
                 <a:solidFill>
                   <a:srgbClr val="222222"/>
                 </a:solidFill>
                 <a:latin typeface="Noto Sans CJK KR"/>
               </a:rPr>
-              <a:t>나머지 조합(S1S4/S4/S5/S6/TARGET) 완주, Pareto 최적점 도출: S2+S4(kf300)+S5(budget235k)+30k = 예상 21~23분/34.4dB</a:t>
+              <a:t>:</a:t>
             </a:r>
           </a:p>
         </p:txBody>
@@ -11611,8 +12304,8 @@
         </p:nvSpPr>
         <p:spPr>
           <a:xfrm>
-            <a:off x="502920" y="1801368"/>
-            <a:ext cx="11185855" cy="320040"/>
+            <a:off x="777240" y="2075688"/>
+            <a:ext cx="10911535" cy="594360"/>
           </a:xfrm>
           <a:prstGeom prst="rect">
             <a:avLst/>
@@ -11626,6 +12319,198 @@
           <a:lstStyle/>
           <a:p>
             <a:r>
+              <a:rPr sz="1300">
+                <a:solidFill>
+                  <a:srgbClr val="555555"/>
+                </a:solidFill>
+                <a:latin typeface="Noto Sans CJK KR"/>
+              </a:rPr>
+              <a:t>– </a:t>
+            </a:r>
+            <a:r>
+              <a:rPr sz="1300" b="1">
+                <a:solidFill>
+                  <a:srgbClr val="555555"/>
+                </a:solidFill>
+                <a:latin typeface="Noto Sans CJK KR"/>
+              </a:rPr>
+              <a:t>RoMA 삼각측량</a:t>
+            </a:r>
+            <a:r>
+              <a:rPr sz="1300" b="0">
+                <a:solidFill>
+                  <a:srgbClr val="555555"/>
+                </a:solidFill>
+                <a:latin typeface="Noto Sans CJK KR"/>
+              </a:rPr>
+              <a:t>: 인접 keyframe 쌍마다 dense correspondence 매칭(certainty&gt;0.5) → 카메라 pose로 삼각측량 → </a:t>
+            </a:r>
+            <a:r>
+              <a:rPr sz="1300" b="1">
+                <a:solidFill>
+                  <a:srgbClr val="555555"/>
+                </a:solidFill>
+                <a:latin typeface="Noto Sans CJK KR"/>
+              </a:rPr>
+              <a:t>재투영 오차 &lt;2px만 채택</a:t>
+            </a:r>
+            <a:r>
+              <a:rPr sz="1300" b="0">
+                <a:solidFill>
+                  <a:srgbClr val="555555"/>
+                </a:solidFill>
+                <a:latin typeface="Noto Sans CJK KR"/>
+              </a:rPr>
+              <a:t>(기하학적으로 검증된 점, frame당 최대 6,000쌍 샘플)</a:t>
+            </a:r>
+          </a:p>
+        </p:txBody>
+      </p:sp>
+      <p:sp>
+        <p:nvSpPr>
+          <p:cNvPr id="7" name="TextBox 6"/>
+          <p:cNvSpPr txBox="1"/>
+          <p:nvPr/>
+        </p:nvSpPr>
+        <p:spPr>
+          <a:xfrm>
+            <a:off x="777240" y="2724912"/>
+            <a:ext cx="10911535" cy="594360"/>
+          </a:xfrm>
+          <a:prstGeom prst="rect">
+            <a:avLst/>
+          </a:prstGeom>
+          <a:noFill/>
+        </p:spPr>
+        <p:txBody>
+          <a:bodyPr wrap="square" lIns="0" tIns="0" bIns="0">
+            <a:spAutoFit/>
+          </a:bodyPr>
+          <a:lstStyle/>
+          <a:p>
+            <a:r>
+              <a:rPr sz="1300">
+                <a:solidFill>
+                  <a:srgbClr val="555555"/>
+                </a:solidFill>
+                <a:latin typeface="Noto Sans CJK KR"/>
+              </a:rPr>
+              <a:t>– </a:t>
+            </a:r>
+            <a:r>
+              <a:rPr sz="1300" b="1">
+                <a:solidFill>
+                  <a:srgbClr val="555555"/>
+                </a:solidFill>
+                <a:latin typeface="Noto Sans CJK KR"/>
+              </a:rPr>
+              <a:t>Sobel-PPM depth-lift</a:t>
+            </a:r>
+            <a:r>
+              <a:rPr sz="1300" b="0">
+                <a:solidFill>
+                  <a:srgbClr val="555555"/>
+                </a:solidFill>
+                <a:latin typeface="Noto Sans CJK KR"/>
+              </a:rPr>
+              <a:t>: 이미지 gradient(Sobel) 크기에 비례한 확률맵으로 픽셀 4,000개/frame 샘플(텍스처 많은 곳에 조밀) → </a:t>
+            </a:r>
+            <a:r>
+              <a:rPr sz="1300" b="1">
+                <a:solidFill>
+                  <a:srgbClr val="555555"/>
+                </a:solidFill>
+                <a:latin typeface="Noto Sans CJK KR"/>
+              </a:rPr>
+              <a:t>SLAM 점으로 Huber 보정한 depth-pro</a:t>
+            </a:r>
+            <a:r>
+              <a:rPr sz="1300" b="0">
+                <a:solidFill>
+                  <a:srgbClr val="555555"/>
+                </a:solidFill>
+                <a:latin typeface="Noto Sans CJK KR"/>
+              </a:rPr>
+              <a:t>로 3D 역투영(스케일 보정 포함)</a:t>
+            </a:r>
+          </a:p>
+        </p:txBody>
+      </p:sp>
+      <p:sp>
+        <p:nvSpPr>
+          <p:cNvPr id="8" name="TextBox 7"/>
+          <p:cNvSpPr txBox="1"/>
+          <p:nvPr/>
+        </p:nvSpPr>
+        <p:spPr>
+          <a:xfrm>
+            <a:off x="777240" y="3374136"/>
+            <a:ext cx="10911535" cy="320040"/>
+          </a:xfrm>
+          <a:prstGeom prst="rect">
+            <a:avLst/>
+          </a:prstGeom>
+          <a:noFill/>
+        </p:spPr>
+        <p:txBody>
+          <a:bodyPr wrap="square" lIns="0" tIns="0" bIns="0">
+            <a:spAutoFit/>
+          </a:bodyPr>
+          <a:lstStyle/>
+          <a:p>
+            <a:r>
+              <a:rPr sz="1300">
+                <a:solidFill>
+                  <a:srgbClr val="555555"/>
+                </a:solidFill>
+                <a:latin typeface="Noto Sans CJK KR"/>
+              </a:rPr>
+              <a:t>– </a:t>
+            </a:r>
+            <a:r>
+              <a:rPr sz="1300" b="1">
+                <a:solidFill>
+                  <a:srgbClr val="555555"/>
+                </a:solidFill>
+                <a:latin typeface="Noto Sans CJK KR"/>
+              </a:rPr>
+              <a:t>원본 SLAM 점</a:t>
+            </a:r>
+            <a:r>
+              <a:rPr sz="1300" b="0">
+                <a:solidFill>
+                  <a:srgbClr val="555555"/>
+                </a:solidFill>
+                <a:latin typeface="Noto Sans CJK KR"/>
+              </a:rPr>
+              <a:t>: 항상 그대로 합류(회색 착색, 항상 신뢰)</a:t>
+            </a:r>
+          </a:p>
+        </p:txBody>
+      </p:sp>
+      <p:sp>
+        <p:nvSpPr>
+          <p:cNvPr id="9" name="TextBox 8"/>
+          <p:cNvSpPr txBox="1"/>
+          <p:nvPr/>
+        </p:nvSpPr>
+        <p:spPr>
+          <a:xfrm>
+            <a:off x="502920" y="3749040"/>
+            <a:ext cx="11185855" cy="320040"/>
+          </a:xfrm>
+          <a:prstGeom prst="rect">
+            <a:avLst/>
+          </a:prstGeom>
+          <a:noFill/>
+        </p:spPr>
+        <p:txBody>
+          <a:bodyPr wrap="square" lIns="0" tIns="0" bIns="0">
+            <a:spAutoFit/>
+          </a:bodyPr>
+          <a:lstStyle/>
+          <a:p>
+            <a:r>
               <a:rPr sz="1500">
                 <a:solidFill>
                   <a:srgbClr val="0F4C81"/>
@@ -11641,7 +12526,7 @@
                 </a:solidFill>
                 <a:latin typeface="Noto Sans CJK KR"/>
               </a:rPr>
-              <a:t>여기서 배치 트랙 우선순위 종료</a:t>
+              <a:t>병합</a:t>
             </a:r>
             <a:r>
               <a:rPr sz="1500" b="0">
@@ -11650,7 +12535,289 @@
                 </a:solidFill>
                 <a:latin typeface="Noto Sans CJK KR"/>
               </a:rPr>
-              <a:t> — 07/15 밤 결정으로 exp48(incremental)이 최우선 과제로 전환</a:t>
+              <a:t>: 4cm voxel에서 dedupe, </a:t>
+            </a:r>
+            <a:r>
+              <a:rPr sz="1500" b="1">
+                <a:solidFill>
+                  <a:srgbClr val="222222"/>
+                </a:solidFill>
+                <a:latin typeface="Noto Sans CJK KR"/>
+              </a:rPr>
+              <a:t>RoMA가 우선권</a:t>
+            </a:r>
+            <a:r>
+              <a:rPr sz="1500" b="0">
+                <a:solidFill>
+                  <a:srgbClr val="222222"/>
+                </a:solidFill>
+                <a:latin typeface="Noto Sans CJK KR"/>
+              </a:rPr>
+              <a:t>(같은 voxel에 RoMA와 PPM 점이 겹치면 RoMA가 남음 — 기하 검증된 점을 우선)</a:t>
+            </a:r>
+          </a:p>
+        </p:txBody>
+      </p:sp>
+      <p:sp>
+        <p:nvSpPr>
+          <p:cNvPr id="10" name="TextBox 9"/>
+          <p:cNvSpPr txBox="1"/>
+          <p:nvPr/>
+        </p:nvSpPr>
+        <p:spPr>
+          <a:xfrm>
+            <a:off x="502920" y="4123944"/>
+            <a:ext cx="11185855" cy="868680"/>
+          </a:xfrm>
+          <a:prstGeom prst="rect">
+            <a:avLst/>
+          </a:prstGeom>
+          <a:noFill/>
+        </p:spPr>
+        <p:txBody>
+          <a:bodyPr wrap="square" lIns="0" tIns="0" bIns="0">
+            <a:spAutoFit/>
+          </a:bodyPr>
+          <a:lstStyle/>
+          <a:p>
+            <a:r>
+              <a:rPr sz="1500">
+                <a:solidFill>
+                  <a:srgbClr val="0F4C81"/>
+                </a:solidFill>
+                <a:latin typeface="Noto Sans CJK KR"/>
+              </a:rPr>
+              <a:t>● </a:t>
+            </a:r>
+            <a:r>
+              <a:rPr sz="1500" b="1">
+                <a:solidFill>
+                  <a:srgbClr val="222222"/>
+                </a:solidFill>
+                <a:latin typeface="Noto Sans CJK KR"/>
+              </a:rPr>
+              <a:t>재필터가 핵심 anchor</a:t>
+            </a:r>
+            <a:r>
+              <a:rPr sz="1500" b="0">
+                <a:solidFill>
+                  <a:srgbClr val="222222"/>
+                </a:solidFill>
+                <a:latin typeface="Noto Sans CJK KR"/>
+              </a:rPr>
+              <a:t>: 병합된 점들에 </a:t>
+            </a:r>
+            <a:r>
+              <a:rPr sz="1500" b="1">
+                <a:solidFill>
+                  <a:srgbClr val="222222"/>
+                </a:solidFill>
+                <a:latin typeface="Noto Sans CJK KR"/>
+              </a:rPr>
+              <a:t>exp43의 depth-anchor field</a:t>
+            </a:r>
+            <a:r>
+              <a:rPr sz="1500" b="0">
+                <a:solidFill>
+                  <a:srgbClr val="222222"/>
+                </a:solidFill>
+                <a:latin typeface="Noto Sans CJK KR"/>
+              </a:rPr>
+              <a:t>(depth-pro를 SLAM으로 보정해 만든 조밀 표면 anchor, depth 추론만 프레임당 ~0.5초)를 기준으로 free-space evidence </a:t>
+            </a:r>
+            <a:r>
+              <a:rPr sz="1500" b="0">
+                <a:solidFill>
+                  <a:srgbClr val="222222"/>
+                </a:solidFill>
+                <a:latin typeface="Noto Sans Mono CJK KR"/>
+              </a:rPr>
+              <a:t>w = ρ(빈공간 증거비) · d5(anchor까지 거리)</a:t>
+            </a:r>
+            <a:r>
+              <a:rPr sz="1500" b="0">
+                <a:solidFill>
+                  <a:srgbClr val="222222"/>
+                </a:solidFill>
+                <a:latin typeface="Noto Sans CJK KR"/>
+              </a:rPr>
+              <a:t> 계산 → </a:t>
+            </a:r>
+            <a:r>
+              <a:rPr sz="1500" b="1">
+                <a:solidFill>
+                  <a:srgbClr val="222222"/>
+                </a:solidFill>
+                <a:latin typeface="Noto Sans CJK KR"/>
+              </a:rPr>
+              <a:t>w&gt;0.5(빈 공간 의심)인 점을 init에 넣기 전에 미리 제거</a:t>
+            </a:r>
+            <a:r>
+              <a:rPr sz="1500" b="0">
+                <a:solidFill>
+                  <a:srgbClr val="222222"/>
+                </a:solidFill>
+                <a:latin typeface="Noto Sans CJK KR"/>
+              </a:rPr>
+              <a:t> — 이게 "먼지는 init에서 잡는다" 원칙의 실제 구현</a:t>
+            </a:r>
+          </a:p>
+        </p:txBody>
+      </p:sp>
+      <p:sp>
+        <p:nvSpPr>
+          <p:cNvPr id="11" name="TextBox 10"/>
+          <p:cNvSpPr txBox="1"/>
+          <p:nvPr/>
+        </p:nvSpPr>
+        <p:spPr>
+          <a:xfrm>
+            <a:off x="502920" y="5047488"/>
+            <a:ext cx="11185855" cy="594360"/>
+          </a:xfrm>
+          <a:prstGeom prst="rect">
+            <a:avLst/>
+          </a:prstGeom>
+          <a:noFill/>
+        </p:spPr>
+        <p:txBody>
+          <a:bodyPr wrap="square" lIns="0" tIns="0" bIns="0">
+            <a:spAutoFit/>
+          </a:bodyPr>
+          <a:lstStyle/>
+          <a:p>
+            <a:r>
+              <a:rPr sz="1500">
+                <a:solidFill>
+                  <a:srgbClr val="0F4C81"/>
+                </a:solidFill>
+                <a:latin typeface="Noto Sans CJK KR"/>
+              </a:rPr>
+              <a:t>● </a:t>
+            </a:r>
+            <a:r>
+              <a:rPr sz="1500" b="1">
+                <a:solidFill>
+                  <a:srgbClr val="222222"/>
+                </a:solidFill>
+                <a:latin typeface="Noto Sans CJK KR"/>
+              </a:rPr>
+              <a:t>왜 SLAM 점만으론 이 재필터가 안 되나</a:t>
+            </a:r>
+            <a:r>
+              <a:rPr sz="1500" b="0">
+                <a:solidFill>
+                  <a:srgbClr val="222222"/>
+                </a:solidFill>
+                <a:latin typeface="Noto Sans CJK KR"/>
+              </a:rPr>
+              <a:t>: exp43 교차 장면 진단 — 305/12F는 </a:t>
+            </a:r>
+            <a:r>
+              <a:rPr sz="1500" b="1">
+                <a:solidFill>
+                  <a:srgbClr val="222222"/>
+                </a:solidFill>
+                <a:latin typeface="Noto Sans CJK KR"/>
+              </a:rPr>
+              <a:t>SLAM 자기NN p50이 0.05m를 넘어</a:t>
+            </a:r>
+            <a:r>
+              <a:rPr sz="1500" b="0">
+                <a:solidFill>
+                  <a:srgbClr val="222222"/>
+                </a:solidFill>
+                <a:latin typeface="Noto Sans CJK KR"/>
+              </a:rPr>
+              <a:t>(1253은 0.042m) "SLAM 근접=표면" 가정이 깨짐(SLAM이 방을 성기게만 덮음) → 앵커를 SLAM 대신 depth-anchor(수십만~백만 점)로 바꿔야 진짜 표면 위치를 기준 삼을 수 있음</a:t>
+            </a:r>
+          </a:p>
+        </p:txBody>
+      </p:sp>
+      <p:sp>
+        <p:nvSpPr>
+          <p:cNvPr id="12" name="TextBox 11"/>
+          <p:cNvSpPr txBox="1"/>
+          <p:nvPr/>
+        </p:nvSpPr>
+        <p:spPr>
+          <a:xfrm>
+            <a:off x="502920" y="5696712"/>
+            <a:ext cx="11185855" cy="320040"/>
+          </a:xfrm>
+          <a:prstGeom prst="rect">
+            <a:avLst/>
+          </a:prstGeom>
+          <a:noFill/>
+        </p:spPr>
+        <p:txBody>
+          <a:bodyPr wrap="square" lIns="0" tIns="0" bIns="0">
+            <a:spAutoFit/>
+          </a:bodyPr>
+          <a:lstStyle/>
+          <a:p>
+            <a:r>
+              <a:rPr sz="1500">
+                <a:solidFill>
+                  <a:srgbClr val="0F4C81"/>
+                </a:solidFill>
+                <a:latin typeface="Noto Sans CJK KR"/>
+              </a:rPr>
+              <a:t>● </a:t>
+            </a:r>
+            <a:r>
+              <a:rPr sz="1500" b="1">
+                <a:solidFill>
+                  <a:srgbClr val="222222"/>
+                </a:solidFill>
+                <a:latin typeface="Noto Sans CJK KR"/>
+              </a:rPr>
+              <a:t>결과 규모</a:t>
+            </a:r>
+            <a:r>
+              <a:rPr sz="1500" b="0">
+                <a:solidFill>
+                  <a:srgbClr val="222222"/>
+                </a:solidFill>
+                <a:latin typeface="Noto Sans CJK KR"/>
+              </a:rPr>
+              <a:t>: 최종 hybrid init 점 수 — 305 </a:t>
+            </a:r>
+            <a:r>
+              <a:rPr sz="1500" b="1">
+                <a:solidFill>
+                  <a:srgbClr val="222222"/>
+                </a:solidFill>
+                <a:latin typeface="Noto Sans CJK KR"/>
+              </a:rPr>
+              <a:t>893,785개</a:t>
+            </a:r>
+            <a:r>
+              <a:rPr sz="1500" b="0">
+                <a:solidFill>
+                  <a:srgbClr val="222222"/>
+                </a:solidFill>
+                <a:latin typeface="Noto Sans CJK KR"/>
+              </a:rPr>
+              <a:t>, 12F </a:t>
+            </a:r>
+            <a:r>
+              <a:rPr sz="1500" b="1">
+                <a:solidFill>
+                  <a:srgbClr val="222222"/>
+                </a:solidFill>
+                <a:latin typeface="Noto Sans CJK KR"/>
+              </a:rPr>
+              <a:t>597,280개</a:t>
+            </a:r>
+            <a:r>
+              <a:rPr sz="1500" b="0">
+                <a:solidFill>
+                  <a:srgbClr val="222222"/>
+                </a:solidFill>
+                <a:latin typeface="Noto Sans CJK KR"/>
+              </a:rPr>
+              <a:t> (SLAM 원본은 각 수천~수만 개 수준에 불과)</a:t>
             </a:r>
           </a:p>
         </p:txBody>
@@ -11702,7 +12869,7 @@
                 </a:solidFill>
                 <a:latin typeface="Noto Sans CJK KR"/>
               </a:rPr>
-              <a:t>슬라이드 5 — exp47: 속도 트랙 — 배치 트랙 실질 종료 — 시각자료</a:t>
+              <a:t>슬라이드 5 — Init 레시피 상세: 어떤 anchor로 만들었나  (계속)</a:t>
             </a:r>
           </a:p>
         </p:txBody>
@@ -11750,64 +12917,16 @@
           </a:p>
         </p:txBody>
       </p:sp>
-      <p:pic>
-        <p:nvPicPr>
-          <p:cNvPr id="4" name="Picture 3" descr="fig_speed_pareto.png"/>
-          <p:cNvPicPr>
-            <a:picLocks noChangeAspect="1"/>
-          </p:cNvPicPr>
-          <p:nvPr/>
-        </p:nvPicPr>
-        <p:blipFill>
-          <a:blip r:embed="rId2"/>
-          <a:stretch>
-            <a:fillRect/>
-          </a:stretch>
-        </p:blipFill>
-        <p:spPr>
-          <a:xfrm>
-            <a:off x="502920" y="1792705"/>
-            <a:ext cx="5455767" cy="3455470"/>
-          </a:xfrm>
-          <a:prstGeom prst="rect">
-            <a:avLst/>
-          </a:prstGeom>
-        </p:spPr>
-      </p:pic>
-      <p:pic>
-        <p:nvPicPr>
-          <p:cNvPr id="5" name="Picture 4" descr="fig_12F_lossless.png"/>
-          <p:cNvPicPr>
-            <a:picLocks noChangeAspect="1"/>
-          </p:cNvPicPr>
-          <p:nvPr/>
-        </p:nvPicPr>
-        <p:blipFill>
-          <a:blip r:embed="rId3"/>
-          <a:stretch>
-            <a:fillRect/>
-          </a:stretch>
-        </p:blipFill>
-        <p:spPr>
-          <a:xfrm>
-            <a:off x="6233007" y="1866768"/>
-            <a:ext cx="5455767" cy="3307342"/>
-          </a:xfrm>
-          <a:prstGeom prst="rect">
-            <a:avLst/>
-          </a:prstGeom>
-        </p:spPr>
-      </p:pic>
-      <p:sp>
-        <p:nvSpPr>
-          <p:cNvPr id="6" name="TextBox 5"/>
+      <p:sp>
+        <p:nvSpPr>
+          <p:cNvPr id="4" name="TextBox 3"/>
           <p:cNvSpPr txBox="1"/>
           <p:nvPr/>
         </p:nvSpPr>
         <p:spPr>
           <a:xfrm>
-            <a:off x="502920" y="5943600"/>
-            <a:ext cx="11185855" cy="777240"/>
+            <a:off x="502920" y="1051560"/>
+            <a:ext cx="11185855" cy="868680"/>
           </a:xfrm>
           <a:prstGeom prst="rect">
             <a:avLst/>
@@ -11815,43 +12934,91 @@
           <a:noFill/>
         </p:spPr>
         <p:txBody>
-          <a:bodyPr wrap="square">
+          <a:bodyPr wrap="square" lIns="0" tIns="0" bIns="0">
             <a:spAutoFit/>
           </a:bodyPr>
           <a:lstStyle/>
           <a:p>
             <a:r>
-              <a:rPr sz="1000">
-                <a:latin typeface="Noto Sans CJK KR"/>
-              </a:rPr>
-              <a:t>🎨 </a:t>
-            </a:r>
-            <a:r>
-              <a:rPr sz="1000" b="0">
-                <a:solidFill>
-                  <a:srgbClr val="8A5A00"/>
-                </a:solidFill>
-                <a:latin typeface="Noto Sans CJK KR"/>
-              </a:rPr>
-              <a:t>① 시간-PSNR Pareto 산점도(8개 축, S2 초록 강조, TARGET 기각 빨강) ② </a:t>
-            </a:r>
-            <a:r>
-              <a:rPr sz="1000" b="1">
-                <a:solidFill>
-                  <a:srgbClr val="8A5A00"/>
-                </a:solidFill>
-                <a:latin typeface="Noto Sans CJK KR"/>
-              </a:rPr>
-              <a:t>같은 카메라 시점 실제 렌더</a:t>
-            </a:r>
-            <a:r>
-              <a:rPr sz="1000" b="0">
-                <a:solidFill>
-                  <a:srgbClr val="8A5A00"/>
-                </a:solidFill>
-                <a:latin typeface="Noto Sans CJK KR"/>
-              </a:rPr>
-              <a:t>로 "무손실" 직접 증명: 기준(66분, PSNR 35.07) vs S2(26.8분, 35.116) — 육안으로 차이를 못 찾을 정도로 동일</a:t>
+              <a:rPr sz="1500">
+                <a:solidFill>
+                  <a:srgbClr val="0F4C81"/>
+                </a:solidFill>
+                <a:latin typeface="Noto Sans CJK KR"/>
+              </a:rPr>
+              <a:t>● </a:t>
+            </a:r>
+            <a:r>
+              <a:rPr sz="1500" b="1">
+                <a:solidFill>
+                  <a:srgbClr val="222222"/>
+                </a:solidFill>
+                <a:latin typeface="Noto Sans CJK KR"/>
+              </a:rPr>
+              <a:t>carve 학습 단계의 anchor는 별개 선택</a:t>
+            </a:r>
+            <a:r>
+              <a:rPr sz="1500" b="0">
+                <a:solidFill>
+                  <a:srgbClr val="222222"/>
+                </a:solidFill>
+                <a:latin typeface="Noto Sans CJK KR"/>
+              </a:rPr>
+              <a:t>: 305는 학습에도 같은 depth-anchor field를 재사용(</a:t>
+            </a:r>
+            <a:r>
+              <a:rPr sz="1500" b="0">
+                <a:solidFill>
+                  <a:srgbClr val="222222"/>
+                </a:solidFill>
+                <a:latin typeface="Noto Sans Mono CJK KR"/>
+              </a:rPr>
+              <a:t>exp43_305_depth.yaml</a:t>
+            </a:r>
+            <a:r>
+              <a:rPr sz="1500" b="0">
+                <a:solidFill>
+                  <a:srgbClr val="222222"/>
+                </a:solidFill>
+                <a:latin typeface="Noto Sans CJK KR"/>
+              </a:rPr>
+              <a:t>)했지만, 12F(축2b)는 SLAM 기반 "control" carve 설정(</a:t>
+            </a:r>
+            <a:r>
+              <a:rPr sz="1500" b="0">
+                <a:solidFill>
+                  <a:srgbClr val="222222"/>
+                </a:solidFill>
+                <a:latin typeface="Noto Sans Mono CJK KR"/>
+              </a:rPr>
+              <a:t>exp43_12F_ctrl.yaml</a:t>
+            </a:r>
+            <a:r>
+              <a:rPr sz="1500" b="0">
+                <a:solidFill>
+                  <a:srgbClr val="222222"/>
+                </a:solidFill>
+                <a:latin typeface="Noto Sans CJK KR"/>
+              </a:rPr>
+              <a:t>, depth-anchor 아님)을 그대로 얹었는데도 −81% 청소에 성공 — </a:t>
+            </a:r>
+            <a:r>
+              <a:rPr sz="1500" b="1">
+                <a:solidFill>
+                  <a:srgbClr val="222222"/>
+                </a:solidFill>
+                <a:latin typeface="Noto Sans CJK KR"/>
+              </a:rPr>
+              <a:t>init 단계에서 이미 depth-anchor로 사전청소가 끝나 있어서, carve 쪽 anchor 정밀도의 중요성이 낮아진 것으로 보임</a:t>
+            </a:r>
+            <a:r>
+              <a:rPr sz="1500" b="0">
+                <a:solidFill>
+                  <a:srgbClr val="222222"/>
+                </a:solidFill>
+                <a:latin typeface="Noto Sans CJK KR"/>
+              </a:rPr>
+              <a:t>(가설, 추가 검증 필요)</a:t>
             </a:r>
           </a:p>
         </p:txBody>

</xml_diff>